<commit_message>
Design-Überarbeitung der Endpräsentation: Icons, Layout-Variation, bessere Lesbarkeit
Co-Authored-By: Claude Sonnet 5.5 <noreply@anthropic.com>
Claude-Session: https://claude.ai/code/session_0111joxY9HLNj7w7Z5tgi3FM
</commit_message>
<xml_diff>
--- a/endpraesentation/Elbharz_Endpraesentation_Geruest.pptx
+++ b/endpraesentation/Elbharz_Endpraesentation_Geruest.pptx
@@ -118,38 +118,38 @@
   <p:extLst>
     <p:ext uri="{521415D9-36F7-43E2-AB2F-B90AF26B5E84}">
       <p14:sectionLst xmlns:p14="http://schemas.microsoft.com/office/powerpoint/2010/main">
-        <p14:section name="Einleitung" id="{b6b04e05-668c-e36d-989c-e567679b332b}">
+        <p14:section name="Einleitung" id="{ff7b473a-1777-88d8-bb7a-b3de1cc8350d}">
           <p14:sldIdLst>
             <p14:sldId id="256"/>
             <p14:sldId id="257"/>
             <p14:sldId id="258"/>
           </p14:sldIdLst>
         </p14:section>
-        <p14:section name="Verlauf der Runden" id="{9c879b94-b50e-b89b-066d-afc76a34a845}">
+        <p14:section name="Verlauf der Runden" id="{69db2324-a497-4912-1220-f62127a58695}">
           <p14:sldIdLst>
             <p14:sldId id="259"/>
             <p14:sldId id="260"/>
             <p14:sldId id="261"/>
           </p14:sldIdLst>
         </p14:section>
-        <p14:section name="Auswertung" id="{816d3718-d507-4990-4482-11ab84240a61}">
+        <p14:section name="Auswertung" id="{c2b2d283-98f9-e959-a9f8-8808c35a2e59}">
           <p14:sldIdLst>
             <p14:sldId id="262"/>
             <p14:sldId id="263"/>
             <p14:sldId id="264"/>
           </p14:sldIdLst>
         </p14:section>
-        <p14:section name="Reflexion" id="{fd732b3f-a1bf-1238-0484-4e18016a11b1}">
+        <p14:section name="Reflexion" id="{c51abd52-c018-2bdc-c471-4569c6635719}">
           <p14:sldIdLst>
             <p14:sldId id="265"/>
           </p14:sldIdLst>
         </p14:section>
-        <p14:section name="Bezug zur Gründung" id="{8f9c903a-73ee-1f43-1e9d-60db86c854fd}">
+        <p14:section name="Bezug zur Gründung" id="{ee985fa3-8cde-6494-d09d-34dafbfe7d29}">
           <p14:sldIdLst>
             <p14:sldId id="266"/>
           </p14:sldIdLst>
         </p14:section>
-        <p14:section name="Abschluss" id="{1325b317-e1bf-31b6-dad3-a2ace293b5de}">
+        <p14:section name="Abschluss" id="{280ed113-8599-8367-2ced-d3e4679223ad}">
           <p14:sldIdLst>
             <p14:sldId id="267"/>
           </p14:sldIdLst>
@@ -1646,7 +1646,7 @@
           <a:lstStyle>
             <a:lvl1pPr algn="l" indent="0" marL="0">
               <a:buNone/>
-              <a:defRPr lang="en-US" sz="3400" b="1" dirty="0">
+              <a:defRPr lang="en-US" sz="3600" b="1" dirty="0">
                 <a:solidFill>
                   <a:schemeClr val="tx2"/>
                 </a:solidFill>
@@ -1660,7 +1660,7 @@
             <a:pPr algn="l" indent="0" marL="0">
               <a:buNone/>
             </a:pPr>
-            <a:endParaRPr lang="en-US" sz="3400" dirty="0"/>
+            <a:endParaRPr lang="en-US" sz="3600" dirty="0"/>
           </a:p>
         </p:txBody>
       </p:sp>
@@ -2128,7 +2128,49 @@
       </p:grpSpPr>
       <p:sp>
         <p:nvSpPr>
-          <p:cNvPr id="2" name="Text 0"/>
+          <p:cNvPr id="2" name="Sonne"/>
+          <p:cNvSpPr/>
+          <p:nvPr/>
+        </p:nvSpPr>
+        <p:spPr>
+          <a:xfrm>
+            <a:off x="8686800" y="1097280"/>
+            <a:ext cx="3108960" cy="3108960"/>
+          </a:xfrm>
+          <a:prstGeom prst="ellipse">
+            <a:avLst/>
+          </a:prstGeom>
+          <a:solidFill>
+            <a:schemeClr val="accent2"/>
+          </a:solidFill>
+          <a:ln/>
+        </p:spPr>
+      </p:sp>
+      <p:sp>
+        <p:nvSpPr>
+          <p:cNvPr id="3" name="Punkt grün"/>
+          <p:cNvSpPr/>
+          <p:nvPr/>
+        </p:nvSpPr>
+        <p:spPr>
+          <a:xfrm>
+            <a:off x="7955280" y="3749040"/>
+            <a:ext cx="1188720" cy="1188720"/>
+          </a:xfrm>
+          <a:prstGeom prst="ellipse">
+            <a:avLst/>
+          </a:prstGeom>
+          <a:solidFill>
+            <a:schemeClr val="accent3">
+              <a:alpha val="75000"/>
+            </a:schemeClr>
+          </a:solidFill>
+          <a:ln/>
+        </p:spPr>
+      </p:sp>
+      <p:sp>
+        <p:nvSpPr>
+          <p:cNvPr id="4" name="Text 2"/>
           <p:cNvSpPr txBox="1"/>
           <p:nvPr/>
         </p:nvSpPr>
@@ -2164,7 +2206,7 @@
       </p:sp>
       <p:sp>
         <p:nvSpPr>
-          <p:cNvPr id="3" name="Text 1"/>
+          <p:cNvPr id="5" name="Text 3"/>
           <p:cNvSpPr txBox="1"/>
           <p:nvPr/>
         </p:nvSpPr>
@@ -2203,14 +2245,14 @@
       </p:sp>
       <p:sp>
         <p:nvSpPr>
-          <p:cNvPr id="4" name="Text 2"/>
+          <p:cNvPr id="6" name="Text 4"/>
           <p:cNvSpPr txBox="1"/>
           <p:nvPr/>
         </p:nvSpPr>
         <p:spPr>
           <a:xfrm>
             <a:off x="822960" y="3200400"/>
-            <a:ext cx="10058400" cy="640080"/>
+            <a:ext cx="6949440" cy="1097280"/>
           </a:xfrm>
           <a:prstGeom prst="rect">
             <a:avLst/>
@@ -2239,7 +2281,7 @@
       </p:sp>
       <p:sp>
         <p:nvSpPr>
-          <p:cNvPr id="5" name="Text 3"/>
+          <p:cNvPr id="7" name="Text 5"/>
           <p:cNvSpPr txBox="1"/>
           <p:nvPr/>
         </p:nvSpPr>
@@ -2325,7 +2367,7 @@
               <a:buNone/>
             </a:pPr>
             <a:r>
-              <a:rPr lang="en-US" sz="3400" b="1" dirty="0">
+              <a:rPr lang="en-US" sz="3600" b="1" dirty="0">
                 <a:solidFill>
                   <a:schemeClr val="tx2"/>
                 </a:solidFill>
@@ -2335,7 +2377,7 @@
               </a:rPr>
               <a:t>Reflexion: Würden wir wieder so entscheiden?</a:t>
             </a:r>
-            <a:endParaRPr lang="en-US" sz="3400" dirty="0"/>
+            <a:endParaRPr lang="en-US" sz="3600" dirty="0"/>
           </a:p>
         </p:txBody>
       </p:sp>
@@ -2348,7 +2390,7 @@
         <p:spPr>
           <a:xfrm>
             <a:off x="640080" y="1463040"/>
-            <a:ext cx="3474720" cy="4480560"/>
+            <a:ext cx="3474720" cy="3566160"/>
           </a:xfrm>
           <a:prstGeom prst="roundRect">
             <a:avLst>
@@ -2363,14 +2405,58 @@
       </p:sp>
       <p:sp>
         <p:nvSpPr>
-          <p:cNvPr id="5" name="Text 2"/>
+          <p:cNvPr id="5" name="Icon-Kreis FaThumbsUp"/>
+          <p:cNvSpPr/>
+          <p:nvPr/>
+        </p:nvSpPr>
+        <p:spPr>
+          <a:xfrm>
+            <a:off x="914400" y="1737360"/>
+            <a:ext cx="640080" cy="640080"/>
+          </a:xfrm>
+          <a:prstGeom prst="ellipse">
+            <a:avLst/>
+          </a:prstGeom>
+          <a:solidFill>
+            <a:schemeClr val="accent3"/>
+          </a:solidFill>
+          <a:ln/>
+        </p:spPr>
+      </p:sp>
+      <p:pic>
+        <p:nvPicPr>
+          <p:cNvPr id="6" name="Icon FaThumbsUp" descr="Symbol">    </p:cNvPr>
+          <p:cNvPicPr>
+            <a:picLocks noChangeAspect="1"/>
+          </p:cNvPicPr>
+          <p:nvPr/>
+        </p:nvPicPr>
+        <p:blipFill>
+          <a:blip r:embed="rId1"/>
+          <a:stretch>
+            <a:fillRect/>
+          </a:stretch>
+        </p:blipFill>
+        <p:spPr>
+          <a:xfrm>
+            <a:off x="1093622" y="1916582"/>
+            <a:ext cx="281635" cy="281635"/>
+          </a:xfrm>
+          <a:prstGeom prst="rect">
+            <a:avLst/>
+          </a:prstGeom>
+        </p:spPr>
+      </p:pic>
+      <p:sp>
+        <p:nvSpPr>
+          <p:cNvPr id="7" name="Text 3"/>
           <p:cNvSpPr txBox="1"/>
           <p:nvPr/>
         </p:nvSpPr>
         <p:spPr>
           <a:xfrm>
-            <a:off x="868680" y="1600200"/>
-            <a:ext cx="3017520" cy="411480"/>
+            <a:off x="1737360" y="1737360"/>
+            <a:ext cx="2103120" cy="640080"/>
           </a:xfrm>
           <a:prstGeom prst="rect">
             <a:avLst/>
@@ -2386,27 +2472,27 @@
               <a:buNone/>
             </a:pPr>
             <a:r>
-              <a:rPr lang="en-US" sz="1800" b="1" dirty="0">
+              <a:rPr lang="en-US" sz="2000" b="1" dirty="0">
                 <a:solidFill>
-                  <a:schemeClr val="accent3"/>
+                  <a:schemeClr val="tx2"/>
                 </a:solidFill>
               </a:rPr>
               <a:t>Das lief gut</a:t>
             </a:r>
-            <a:endParaRPr lang="en-US" sz="1800" dirty="0"/>
+            <a:endParaRPr lang="en-US" sz="2000" dirty="0"/>
           </a:p>
         </p:txBody>
       </p:sp>
       <p:sp>
         <p:nvSpPr>
-          <p:cNvPr id="6" name="Text 3"/>
+          <p:cNvPr id="8" name="Text 4"/>
           <p:cNvSpPr txBox="1"/>
           <p:nvPr/>
         </p:nvSpPr>
         <p:spPr>
           <a:xfrm>
-            <a:off x="868680" y="2057400"/>
-            <a:ext cx="3017520" cy="3749040"/>
+            <a:off x="914400" y="2651760"/>
+            <a:ext cx="2926080" cy="2194560"/>
           </a:xfrm>
           <a:prstGeom prst="rect">
             <a:avLst/>
@@ -2417,6 +2503,419 @@
         <p:txBody>
           <a:bodyPr wrap="square" lIns="0" tIns="0" rIns="0" bIns="0" rtlCol="0" anchor="t"/>
           <a:lstStyle/>
+          <a:p>
+            <a:pPr indent="0" marL="0">
+              <a:spcAft>
+                <a:spcPts val="600"/>
+              </a:spcAft>
+              <a:buNone/>
+            </a:pPr>
+            <a:r>
+              <a:rPr lang="en-US" sz="1600" dirty="0">
+                <a:solidFill>
+                  <a:schemeClr val="tx1"/>
+                </a:solidFill>
+              </a:rPr>
+              <a:t>– Entscheidung 1: Begründung</a:t>
+            </a:r>
+            <a:endParaRPr lang="en-US" sz="1600" dirty="0"/>
+          </a:p>
+          <a:p>
+            <a:pPr indent="0" marL="0">
+              <a:spcAft>
+                <a:spcPts val="600"/>
+              </a:spcAft>
+              <a:buNone/>
+            </a:pPr>
+            <a:r>
+              <a:rPr lang="en-US" sz="1600" dirty="0">
+                <a:solidFill>
+                  <a:schemeClr val="tx1"/>
+                </a:solidFill>
+              </a:rPr>
+              <a:t>– Entscheidung 2: Begründung</a:t>
+            </a:r>
+            <a:endParaRPr lang="en-US" sz="1600" dirty="0"/>
+          </a:p>
+        </p:txBody>
+      </p:sp>
+      <p:sp>
+        <p:nvSpPr>
+          <p:cNvPr id="9" name="Karte Das lief schlechter"/>
+          <p:cNvSpPr/>
+          <p:nvPr/>
+        </p:nvSpPr>
+        <p:spPr>
+          <a:xfrm>
+            <a:off x="4343400" y="1463040"/>
+            <a:ext cx="3474720" cy="3566160"/>
+          </a:xfrm>
+          <a:prstGeom prst="roundRect">
+            <a:avLst>
+              <a:gd name="adj" fmla="val 3158"/>
+            </a:avLst>
+          </a:prstGeom>
+          <a:solidFill>
+            <a:schemeClr val="bg2"/>
+          </a:solidFill>
+          <a:ln/>
+        </p:spPr>
+      </p:sp>
+      <p:sp>
+        <p:nvSpPr>
+          <p:cNvPr id="10" name="Icon-Kreis FaThumbsDown"/>
+          <p:cNvSpPr/>
+          <p:nvPr/>
+        </p:nvSpPr>
+        <p:spPr>
+          <a:xfrm>
+            <a:off x="4617720" y="1737360"/>
+            <a:ext cx="640080" cy="640080"/>
+          </a:xfrm>
+          <a:prstGeom prst="ellipse">
+            <a:avLst/>
+          </a:prstGeom>
+          <a:solidFill>
+            <a:schemeClr val="accent2"/>
+          </a:solidFill>
+          <a:ln/>
+        </p:spPr>
+      </p:sp>
+      <p:pic>
+        <p:nvPicPr>
+          <p:cNvPr id="11" name="Icon FaThumbsDown" descr="Symbol">    </p:cNvPr>
+          <p:cNvPicPr>
+            <a:picLocks noChangeAspect="1"/>
+          </p:cNvPicPr>
+          <p:nvPr/>
+        </p:nvPicPr>
+        <p:blipFill>
+          <a:blip r:embed="rId2"/>
+          <a:stretch>
+            <a:fillRect/>
+          </a:stretch>
+        </p:blipFill>
+        <p:spPr>
+          <a:xfrm>
+            <a:off x="4796942" y="1916582"/>
+            <a:ext cx="281635" cy="281635"/>
+          </a:xfrm>
+          <a:prstGeom prst="rect">
+            <a:avLst/>
+          </a:prstGeom>
+        </p:spPr>
+      </p:pic>
+      <p:sp>
+        <p:nvSpPr>
+          <p:cNvPr id="12" name="Text 7"/>
+          <p:cNvSpPr txBox="1"/>
+          <p:nvPr/>
+        </p:nvSpPr>
+        <p:spPr>
+          <a:xfrm>
+            <a:off x="5440680" y="1737360"/>
+            <a:ext cx="2103120" cy="640080"/>
+          </a:xfrm>
+          <a:prstGeom prst="rect">
+            <a:avLst/>
+          </a:prstGeom>
+          <a:noFill/>
+          <a:ln/>
+        </p:spPr>
+        <p:txBody>
+          <a:bodyPr wrap="square" lIns="0" tIns="0" rIns="0" bIns="0" rtlCol="0" anchor="ctr"/>
+          <a:lstStyle/>
+          <a:p>
+            <a:pPr indent="0" marL="0">
+              <a:buNone/>
+            </a:pPr>
+            <a:r>
+              <a:rPr lang="en-US" sz="2000" b="1" dirty="0">
+                <a:solidFill>
+                  <a:schemeClr val="tx2"/>
+                </a:solidFill>
+              </a:rPr>
+              <a:t>Das lief schlechter</a:t>
+            </a:r>
+            <a:endParaRPr lang="en-US" sz="2000" dirty="0"/>
+          </a:p>
+        </p:txBody>
+      </p:sp>
+      <p:sp>
+        <p:nvSpPr>
+          <p:cNvPr id="13" name="Text 8"/>
+          <p:cNvSpPr txBox="1"/>
+          <p:nvPr/>
+        </p:nvSpPr>
+        <p:spPr>
+          <a:xfrm>
+            <a:off x="4617720" y="2651760"/>
+            <a:ext cx="2926080" cy="2194560"/>
+          </a:xfrm>
+          <a:prstGeom prst="rect">
+            <a:avLst/>
+          </a:prstGeom>
+          <a:noFill/>
+          <a:ln/>
+        </p:spPr>
+        <p:txBody>
+          <a:bodyPr wrap="square" lIns="0" tIns="0" rIns="0" bIns="0" rtlCol="0" anchor="t"/>
+          <a:lstStyle/>
+          <a:p>
+            <a:pPr indent="0" marL="0">
+              <a:spcAft>
+                <a:spcPts val="600"/>
+              </a:spcAft>
+              <a:buNone/>
+            </a:pPr>
+            <a:r>
+              <a:rPr lang="en-US" sz="1600" dirty="0">
+                <a:solidFill>
+                  <a:schemeClr val="tx1"/>
+                </a:solidFill>
+              </a:rPr>
+              <a:t>– Entscheidung 1: Begründung</a:t>
+            </a:r>
+            <a:endParaRPr lang="en-US" sz="1600" dirty="0"/>
+          </a:p>
+          <a:p>
+            <a:pPr indent="0" marL="0">
+              <a:spcAft>
+                <a:spcPts val="600"/>
+              </a:spcAft>
+              <a:buNone/>
+            </a:pPr>
+            <a:r>
+              <a:rPr lang="en-US" sz="1600" dirty="0">
+                <a:solidFill>
+                  <a:schemeClr val="tx1"/>
+                </a:solidFill>
+              </a:rPr>
+              <a:t>– Entscheidung 2: Begründung</a:t>
+            </a:r>
+            <a:endParaRPr lang="en-US" sz="1600" dirty="0"/>
+          </a:p>
+        </p:txBody>
+      </p:sp>
+      <p:sp>
+        <p:nvSpPr>
+          <p:cNvPr id="14" name="Karte Alternativen"/>
+          <p:cNvSpPr/>
+          <p:nvPr/>
+        </p:nvSpPr>
+        <p:spPr>
+          <a:xfrm>
+            <a:off x="8046720" y="1463040"/>
+            <a:ext cx="3474720" cy="3566160"/>
+          </a:xfrm>
+          <a:prstGeom prst="roundRect">
+            <a:avLst>
+              <a:gd name="adj" fmla="val 3158"/>
+            </a:avLst>
+          </a:prstGeom>
+          <a:solidFill>
+            <a:schemeClr val="bg2"/>
+          </a:solidFill>
+          <a:ln/>
+        </p:spPr>
+      </p:sp>
+      <p:sp>
+        <p:nvSpPr>
+          <p:cNvPr id="15" name="Icon-Kreis FaExchangeAlt"/>
+          <p:cNvSpPr/>
+          <p:nvPr/>
+        </p:nvSpPr>
+        <p:spPr>
+          <a:xfrm>
+            <a:off x="8321040" y="1737360"/>
+            <a:ext cx="640080" cy="640080"/>
+          </a:xfrm>
+          <a:prstGeom prst="ellipse">
+            <a:avLst/>
+          </a:prstGeom>
+          <a:solidFill>
+            <a:schemeClr val="accent1"/>
+          </a:solidFill>
+          <a:ln/>
+        </p:spPr>
+      </p:sp>
+      <p:pic>
+        <p:nvPicPr>
+          <p:cNvPr id="16" name="Icon FaExchangeAlt" descr="Symbol">    </p:cNvPr>
+          <p:cNvPicPr>
+            <a:picLocks noChangeAspect="1"/>
+          </p:cNvPicPr>
+          <p:nvPr/>
+        </p:nvPicPr>
+        <p:blipFill>
+          <a:blip r:embed="rId3"/>
+          <a:stretch>
+            <a:fillRect/>
+          </a:stretch>
+        </p:blipFill>
+        <p:spPr>
+          <a:xfrm>
+            <a:off x="8500262" y="1916582"/>
+            <a:ext cx="281635" cy="281635"/>
+          </a:xfrm>
+          <a:prstGeom prst="rect">
+            <a:avLst/>
+          </a:prstGeom>
+        </p:spPr>
+      </p:pic>
+      <p:sp>
+        <p:nvSpPr>
+          <p:cNvPr id="17" name="Text 11"/>
+          <p:cNvSpPr txBox="1"/>
+          <p:nvPr/>
+        </p:nvSpPr>
+        <p:spPr>
+          <a:xfrm>
+            <a:off x="9144000" y="1737360"/>
+            <a:ext cx="2103120" cy="640080"/>
+          </a:xfrm>
+          <a:prstGeom prst="rect">
+            <a:avLst/>
+          </a:prstGeom>
+          <a:noFill/>
+          <a:ln/>
+        </p:spPr>
+        <p:txBody>
+          <a:bodyPr wrap="square" lIns="0" tIns="0" rIns="0" bIns="0" rtlCol="0" anchor="ctr"/>
+          <a:lstStyle/>
+          <a:p>
+            <a:pPr indent="0" marL="0">
+              <a:buNone/>
+            </a:pPr>
+            <a:r>
+              <a:rPr lang="en-US" sz="2000" b="1" dirty="0">
+                <a:solidFill>
+                  <a:schemeClr val="tx2"/>
+                </a:solidFill>
+              </a:rPr>
+              <a:t>Alternativen</a:t>
+            </a:r>
+            <a:endParaRPr lang="en-US" sz="2000" dirty="0"/>
+          </a:p>
+        </p:txBody>
+      </p:sp>
+      <p:sp>
+        <p:nvSpPr>
+          <p:cNvPr id="18" name="Text 12"/>
+          <p:cNvSpPr txBox="1"/>
+          <p:nvPr/>
+        </p:nvSpPr>
+        <p:spPr>
+          <a:xfrm>
+            <a:off x="8321040" y="2651760"/>
+            <a:ext cx="2926080" cy="2194560"/>
+          </a:xfrm>
+          <a:prstGeom prst="rect">
+            <a:avLst/>
+          </a:prstGeom>
+          <a:noFill/>
+          <a:ln/>
+        </p:spPr>
+        <p:txBody>
+          <a:bodyPr wrap="square" lIns="0" tIns="0" rIns="0" bIns="0" rtlCol="0" anchor="t"/>
+          <a:lstStyle/>
+          <a:p>
+            <a:pPr indent="0" marL="0">
+              <a:spcAft>
+                <a:spcPts val="600"/>
+              </a:spcAft>
+              <a:buNone/>
+            </a:pPr>
+            <a:r>
+              <a:rPr lang="en-US" sz="1600" dirty="0">
+                <a:solidFill>
+                  <a:schemeClr val="tx1"/>
+                </a:solidFill>
+              </a:rPr>
+              <a:t>– Statt X hätten wir Y tun können</a:t>
+            </a:r>
+            <a:endParaRPr lang="en-US" sz="1600" dirty="0"/>
+          </a:p>
+          <a:p>
+            <a:pPr indent="0" marL="0">
+              <a:spcAft>
+                <a:spcPts val="600"/>
+              </a:spcAft>
+              <a:buNone/>
+            </a:pPr>
+            <a:r>
+              <a:rPr lang="en-US" sz="1600" dirty="0">
+                <a:solidFill>
+                  <a:schemeClr val="tx1"/>
+                </a:solidFill>
+              </a:rPr>
+              <a:t>– Erwartete Wirkung auf den Unternehmenswert</a:t>
+            </a:r>
+            <a:endParaRPr lang="en-US" sz="1600" dirty="0"/>
+          </a:p>
+        </p:txBody>
+      </p:sp>
+      <p:sp>
+        <p:nvSpPr>
+          <p:cNvPr id="19" name="Platzhalter"/>
+          <p:cNvSpPr/>
+          <p:nvPr/>
+        </p:nvSpPr>
+        <p:spPr>
+          <a:xfrm>
+            <a:off x="640080" y="5257800"/>
+            <a:ext cx="10881360" cy="868680"/>
+          </a:xfrm>
+          <a:prstGeom prst="roundRect">
+            <a:avLst>
+              <a:gd name="adj" fmla="val 12632"/>
+            </a:avLst>
+          </a:prstGeom>
+          <a:solidFill>
+            <a:schemeClr val="bg2"/>
+          </a:solidFill>
+          <a:ln w="15875">
+            <a:solidFill>
+              <a:schemeClr val="accent5"/>
+            </a:solidFill>
+            <a:prstDash val="dash"/>
+          </a:ln>
+        </p:spPr>
+      </p:sp>
+      <p:sp>
+        <p:nvSpPr>
+          <p:cNvPr id="20" name="Text 14"/>
+          <p:cNvSpPr txBox="1"/>
+          <p:nvPr/>
+        </p:nvSpPr>
+        <p:spPr>
+          <a:xfrm>
+            <a:off x="868680" y="5257800"/>
+            <a:ext cx="10424160" cy="868680"/>
+          </a:xfrm>
+          <a:prstGeom prst="rect">
+            <a:avLst/>
+          </a:prstGeom>
+          <a:noFill/>
+          <a:ln/>
+        </p:spPr>
+        <p:txBody>
+          <a:bodyPr wrap="square" lIns="0" tIns="0" rIns="0" bIns="0" rtlCol="0" anchor="ctr"/>
+          <a:lstStyle/>
+          <a:p>
+            <a:pPr indent="0" marL="0">
+              <a:buNone/>
+            </a:pPr>
+            <a:r>
+              <a:rPr lang="en-US" sz="1600" b="1" dirty="0">
+                <a:solidFill>
+                  <a:schemeClr val="tx2"/>
+                </a:solidFill>
+              </a:rPr>
+              <a:t>Gesamtfazit</a:t>
+            </a:r>
+            <a:endParaRPr lang="en-US" sz="1600" dirty="0"/>
+          </a:p>
           <a:p>
             <a:pPr indent="0" marL="0">
               <a:buNone/>
@@ -2427,239 +2926,9 @@
                   <a:schemeClr val="tx1"/>
                 </a:solidFill>
               </a:rPr>
-              <a:t>– Entscheidung 1: Begründung</a:t>
+              <a:t>Würden wir als Gruppe insgesamt wieder so vorgehen? Ein Satz</a:t>
             </a:r>
-            <a:endParaRPr lang="en-US" sz="1400" dirty="0"/>
-          </a:p>
-          <a:p>
-            <a:pPr indent="0" marL="0">
-              <a:buNone/>
-            </a:pPr>
-            <a:r>
-              <a:rPr lang="en-US" sz="1400" dirty="0">
-                <a:solidFill>
-                  <a:schemeClr val="tx1"/>
-                </a:solidFill>
-              </a:rPr>
-              <a:t>– Entscheidung 2: Begründung</a:t>
-            </a:r>
-            <a:endParaRPr lang="en-US" sz="1400" dirty="0"/>
-          </a:p>
-        </p:txBody>
-      </p:sp>
-      <p:sp>
-        <p:nvSpPr>
-          <p:cNvPr id="7" name="Karte Das lief schlechter"/>
-          <p:cNvSpPr/>
-          <p:nvPr/>
-        </p:nvSpPr>
-        <p:spPr>
-          <a:xfrm>
-            <a:off x="4343400" y="1463040"/>
-            <a:ext cx="3474720" cy="4480560"/>
-          </a:xfrm>
-          <a:prstGeom prst="roundRect">
-            <a:avLst>
-              <a:gd name="adj" fmla="val 3158"/>
-            </a:avLst>
-          </a:prstGeom>
-          <a:solidFill>
-            <a:schemeClr val="bg2"/>
-          </a:solidFill>
-          <a:ln/>
-        </p:spPr>
-      </p:sp>
-      <p:sp>
-        <p:nvSpPr>
-          <p:cNvPr id="8" name="Text 5"/>
-          <p:cNvSpPr txBox="1"/>
-          <p:nvPr/>
-        </p:nvSpPr>
-        <p:spPr>
-          <a:xfrm>
-            <a:off x="4572000" y="1600200"/>
-            <a:ext cx="3017520" cy="411480"/>
-          </a:xfrm>
-          <a:prstGeom prst="rect">
-            <a:avLst/>
-          </a:prstGeom>
-          <a:noFill/>
-          <a:ln/>
-        </p:spPr>
-        <p:txBody>
-          <a:bodyPr wrap="square" lIns="0" tIns="0" rIns="0" bIns="0" rtlCol="0" anchor="ctr"/>
-          <a:lstStyle/>
-          <a:p>
-            <a:pPr indent="0" marL="0">
-              <a:buNone/>
-            </a:pPr>
-            <a:r>
-              <a:rPr lang="en-US" sz="1800" b="1" dirty="0">
-                <a:solidFill>
-                  <a:schemeClr val="accent2"/>
-                </a:solidFill>
-              </a:rPr>
-              <a:t>Das lief schlechter</a:t>
-            </a:r>
-            <a:endParaRPr lang="en-US" sz="1800" dirty="0"/>
-          </a:p>
-        </p:txBody>
-      </p:sp>
-      <p:sp>
-        <p:nvSpPr>
-          <p:cNvPr id="9" name="Text 6"/>
-          <p:cNvSpPr txBox="1"/>
-          <p:nvPr/>
-        </p:nvSpPr>
-        <p:spPr>
-          <a:xfrm>
-            <a:off x="4572000" y="2057400"/>
-            <a:ext cx="3017520" cy="3749040"/>
-          </a:xfrm>
-          <a:prstGeom prst="rect">
-            <a:avLst/>
-          </a:prstGeom>
-          <a:noFill/>
-          <a:ln/>
-        </p:spPr>
-        <p:txBody>
-          <a:bodyPr wrap="square" lIns="0" tIns="0" rIns="0" bIns="0" rtlCol="0" anchor="t"/>
-          <a:lstStyle/>
-          <a:p>
-            <a:pPr indent="0" marL="0">
-              <a:buNone/>
-            </a:pPr>
-            <a:r>
-              <a:rPr lang="en-US" sz="1400" dirty="0">
-                <a:solidFill>
-                  <a:schemeClr val="tx1"/>
-                </a:solidFill>
-              </a:rPr>
-              <a:t>– Entscheidung 1: Begründung</a:t>
-            </a:r>
-            <a:endParaRPr lang="en-US" sz="1400" dirty="0"/>
-          </a:p>
-          <a:p>
-            <a:pPr indent="0" marL="0">
-              <a:buNone/>
-            </a:pPr>
-            <a:r>
-              <a:rPr lang="en-US" sz="1400" dirty="0">
-                <a:solidFill>
-                  <a:schemeClr val="tx1"/>
-                </a:solidFill>
-              </a:rPr>
-              <a:t>– Entscheidung 2: Begründung</a:t>
-            </a:r>
-            <a:endParaRPr lang="en-US" sz="1400" dirty="0"/>
-          </a:p>
-        </p:txBody>
-      </p:sp>
-      <p:sp>
-        <p:nvSpPr>
-          <p:cNvPr id="10" name="Karte Handlungsalternativen"/>
-          <p:cNvSpPr/>
-          <p:nvPr/>
-        </p:nvSpPr>
-        <p:spPr>
-          <a:xfrm>
-            <a:off x="8046720" y="1463040"/>
-            <a:ext cx="3474720" cy="4480560"/>
-          </a:xfrm>
-          <a:prstGeom prst="roundRect">
-            <a:avLst>
-              <a:gd name="adj" fmla="val 3158"/>
-            </a:avLst>
-          </a:prstGeom>
-          <a:solidFill>
-            <a:schemeClr val="bg2"/>
-          </a:solidFill>
-          <a:ln/>
-        </p:spPr>
-      </p:sp>
-      <p:sp>
-        <p:nvSpPr>
-          <p:cNvPr id="11" name="Text 8"/>
-          <p:cNvSpPr txBox="1"/>
-          <p:nvPr/>
-        </p:nvSpPr>
-        <p:spPr>
-          <a:xfrm>
-            <a:off x="8275320" y="1600200"/>
-            <a:ext cx="3017520" cy="411480"/>
-          </a:xfrm>
-          <a:prstGeom prst="rect">
-            <a:avLst/>
-          </a:prstGeom>
-          <a:noFill/>
-          <a:ln/>
-        </p:spPr>
-        <p:txBody>
-          <a:bodyPr wrap="square" lIns="0" tIns="0" rIns="0" bIns="0" rtlCol="0" anchor="ctr"/>
-          <a:lstStyle/>
-          <a:p>
-            <a:pPr indent="0" marL="0">
-              <a:buNone/>
-            </a:pPr>
-            <a:r>
-              <a:rPr lang="en-US" sz="1800" b="1" dirty="0">
-                <a:solidFill>
-                  <a:schemeClr val="tx2"/>
-                </a:solidFill>
-              </a:rPr>
-              <a:t>Handlungsalternativen</a:t>
-            </a:r>
-            <a:endParaRPr lang="en-US" sz="1800" dirty="0"/>
-          </a:p>
-        </p:txBody>
-      </p:sp>
-      <p:sp>
-        <p:nvSpPr>
-          <p:cNvPr id="12" name="Text 9"/>
-          <p:cNvSpPr txBox="1"/>
-          <p:nvPr/>
-        </p:nvSpPr>
-        <p:spPr>
-          <a:xfrm>
-            <a:off x="8275320" y="2057400"/>
-            <a:ext cx="3017520" cy="3749040"/>
-          </a:xfrm>
-          <a:prstGeom prst="rect">
-            <a:avLst/>
-          </a:prstGeom>
-          <a:noFill/>
-          <a:ln/>
-        </p:spPr>
-        <p:txBody>
-          <a:bodyPr wrap="square" lIns="0" tIns="0" rIns="0" bIns="0" rtlCol="0" anchor="t"/>
-          <a:lstStyle/>
-          <a:p>
-            <a:pPr indent="0" marL="0">
-              <a:buNone/>
-            </a:pPr>
-            <a:r>
-              <a:rPr lang="en-US" sz="1400" dirty="0">
-                <a:solidFill>
-                  <a:schemeClr val="tx1"/>
-                </a:solidFill>
-              </a:rPr>
-              <a:t>– Statt X hätten wir Y tun können</a:t>
-            </a:r>
-            <a:endParaRPr lang="en-US" sz="1400" dirty="0"/>
-          </a:p>
-          <a:p>
-            <a:pPr indent="0" marL="0">
-              <a:buNone/>
-            </a:pPr>
-            <a:r>
-              <a:rPr lang="en-US" sz="1400" dirty="0">
-                <a:solidFill>
-                  <a:schemeClr val="tx1"/>
-                </a:solidFill>
-              </a:rPr>
-              <a:t>– Erwartete Wirkung auf den Unternehmenswert</a:t>
-            </a:r>
-            <a:endParaRPr lang="en-US" sz="1400" dirty="0"/>
+            <a:endParaRPr lang="en-US" sz="1600" dirty="0"/>
           </a:p>
         </p:txBody>
       </p:sp>
@@ -2760,7 +3029,7 @@
               <a:buNone/>
             </a:pPr>
             <a:r>
-              <a:rPr lang="en-US" sz="3400" b="1" dirty="0">
+              <a:rPr lang="en-US" sz="3600" b="1" dirty="0">
                 <a:solidFill>
                   <a:schemeClr val="tx2"/>
                 </a:solidFill>
@@ -2770,7 +3039,7 @@
               </a:rPr>
               <a:t>Bezug zur Gründung: was im Spiel fehlte</a:t>
             </a:r>
-            <a:endParaRPr lang="en-US" sz="3400" dirty="0"/>
+            <a:endParaRPr lang="en-US" sz="3600" dirty="0"/>
           </a:p>
         </p:txBody>
       </p:sp>
@@ -2783,7 +3052,7 @@
         <p:spPr>
           <a:xfrm>
             <a:off x="640080" y="1463040"/>
-            <a:ext cx="3474720" cy="4480560"/>
+            <a:ext cx="3474720" cy="3566160"/>
           </a:xfrm>
           <a:prstGeom prst="roundRect">
             <a:avLst>
@@ -2798,14 +3067,58 @@
       </p:sp>
       <p:sp>
         <p:nvSpPr>
-          <p:cNvPr id="5" name="Text 2"/>
+          <p:cNvPr id="5" name="Icon-Kreis FaBan"/>
+          <p:cNvSpPr/>
+          <p:nvPr/>
+        </p:nvSpPr>
+        <p:spPr>
+          <a:xfrm>
+            <a:off x="914400" y="1737360"/>
+            <a:ext cx="640080" cy="640080"/>
+          </a:xfrm>
+          <a:prstGeom prst="ellipse">
+            <a:avLst/>
+          </a:prstGeom>
+          <a:solidFill>
+            <a:schemeClr val="accent1"/>
+          </a:solidFill>
+          <a:ln/>
+        </p:spPr>
+      </p:sp>
+      <p:pic>
+        <p:nvPicPr>
+          <p:cNvPr id="6" name="Icon FaBan" descr="Symbol">    </p:cNvPr>
+          <p:cNvPicPr>
+            <a:picLocks noChangeAspect="1"/>
+          </p:cNvPicPr>
+          <p:nvPr/>
+        </p:nvPicPr>
+        <p:blipFill>
+          <a:blip r:embed="rId1"/>
+          <a:stretch>
+            <a:fillRect/>
+          </a:stretch>
+        </p:blipFill>
+        <p:spPr>
+          <a:xfrm>
+            <a:off x="1093622" y="1916582"/>
+            <a:ext cx="281635" cy="281635"/>
+          </a:xfrm>
+          <a:prstGeom prst="rect">
+            <a:avLst/>
+          </a:prstGeom>
+        </p:spPr>
+      </p:pic>
+      <p:sp>
+        <p:nvSpPr>
+          <p:cNvPr id="7" name="Text 3"/>
           <p:cNvSpPr txBox="1"/>
           <p:nvPr/>
         </p:nvSpPr>
         <p:spPr>
           <a:xfrm>
-            <a:off x="868680" y="1600200"/>
-            <a:ext cx="3017520" cy="411480"/>
+            <a:off x="1737360" y="1737360"/>
+            <a:ext cx="2103120" cy="640080"/>
           </a:xfrm>
           <a:prstGeom prst="rect">
             <a:avLst/>
@@ -2821,27 +3134,27 @@
               <a:buNone/>
             </a:pPr>
             <a:r>
-              <a:rPr lang="en-US" sz="1800" b="1" dirty="0">
+              <a:rPr lang="en-US" sz="2000" b="1" dirty="0">
                 <a:solidFill>
                   <a:schemeClr val="tx2"/>
                 </a:solidFill>
               </a:rPr>
               <a:t>Nicht im Spiel</a:t>
             </a:r>
-            <a:endParaRPr lang="en-US" sz="1800" dirty="0"/>
+            <a:endParaRPr lang="en-US" sz="2000" dirty="0"/>
           </a:p>
         </p:txBody>
       </p:sp>
       <p:sp>
         <p:nvSpPr>
-          <p:cNvPr id="6" name="Text 3"/>
+          <p:cNvPr id="8" name="Text 4"/>
           <p:cNvSpPr txBox="1"/>
           <p:nvPr/>
         </p:nvSpPr>
         <p:spPr>
           <a:xfrm>
-            <a:off x="868680" y="2057400"/>
-            <a:ext cx="3017520" cy="3749040"/>
+            <a:off x="914400" y="2651760"/>
+            <a:ext cx="2926080" cy="2194560"/>
           </a:xfrm>
           <a:prstGeom prst="rect">
             <a:avLst/>
@@ -2852,6 +3165,436 @@
         <p:txBody>
           <a:bodyPr wrap="square" lIns="0" tIns="0" rIns="0" bIns="0" rtlCol="0" anchor="t"/>
           <a:lstStyle/>
+          <a:p>
+            <a:pPr indent="0" marL="0">
+              <a:spcAft>
+                <a:spcPts val="600"/>
+              </a:spcAft>
+              <a:buNone/>
+            </a:pPr>
+            <a:r>
+              <a:rPr lang="en-US" sz="1600" dirty="0">
+                <a:solidFill>
+                  <a:schemeClr val="tx1"/>
+                </a:solidFill>
+              </a:rPr>
+              <a:t>– Mehrweg-Glas und Pfand</a:t>
+            </a:r>
+            <a:endParaRPr lang="en-US" sz="1600" dirty="0"/>
+          </a:p>
+          <a:p>
+            <a:pPr indent="0" marL="0">
+              <a:spcAft>
+                <a:spcPts val="600"/>
+              </a:spcAft>
+              <a:buNone/>
+            </a:pPr>
+            <a:r>
+              <a:rPr lang="en-US" sz="1600" dirty="0">
+                <a:solidFill>
+                  <a:schemeClr val="tx1"/>
+                </a:solidFill>
+              </a:rPr>
+              <a:t>– Social-Media-Marketing / Onlineshop</a:t>
+            </a:r>
+            <a:endParaRPr lang="en-US" sz="1600" dirty="0"/>
+          </a:p>
+          <a:p>
+            <a:pPr indent="0" marL="0">
+              <a:spcAft>
+                <a:spcPts val="600"/>
+              </a:spcAft>
+              <a:buNone/>
+            </a:pPr>
+            <a:r>
+              <a:rPr lang="en-US" sz="1600" dirty="0">
+                <a:solidFill>
+                  <a:schemeClr val="tx1"/>
+                </a:solidFill>
+              </a:rPr>
+              <a:t>– Nur eine Sorte, Tamarinde</a:t>
+            </a:r>
+            <a:endParaRPr lang="en-US" sz="1600" dirty="0"/>
+          </a:p>
+          <a:p>
+            <a:pPr indent="0" marL="0">
+              <a:spcAft>
+                <a:spcPts val="600"/>
+              </a:spcAft>
+              <a:buNone/>
+            </a:pPr>
+            <a:r>
+              <a:rPr lang="en-US" sz="1600" dirty="0">
+                <a:solidFill>
+                  <a:schemeClr val="tx1"/>
+                </a:solidFill>
+              </a:rPr>
+              <a:t>– Zielgruppe, Vertriebsweg</a:t>
+            </a:r>
+            <a:endParaRPr lang="en-US" sz="1600" dirty="0"/>
+          </a:p>
+        </p:txBody>
+      </p:sp>
+      <p:sp>
+        <p:nvSpPr>
+          <p:cNvPr id="9" name="Karte Mögliche Auswirkung"/>
+          <p:cNvSpPr/>
+          <p:nvPr/>
+        </p:nvSpPr>
+        <p:spPr>
+          <a:xfrm>
+            <a:off x="4343400" y="1463040"/>
+            <a:ext cx="3474720" cy="3566160"/>
+          </a:xfrm>
+          <a:prstGeom prst="roundRect">
+            <a:avLst>
+              <a:gd name="adj" fmla="val 3158"/>
+            </a:avLst>
+          </a:prstGeom>
+          <a:solidFill>
+            <a:schemeClr val="bg2"/>
+          </a:solidFill>
+          <a:ln/>
+        </p:spPr>
+      </p:sp>
+      <p:sp>
+        <p:nvSpPr>
+          <p:cNvPr id="10" name="Icon-Kreis FaChartLine"/>
+          <p:cNvSpPr/>
+          <p:nvPr/>
+        </p:nvSpPr>
+        <p:spPr>
+          <a:xfrm>
+            <a:off x="4617720" y="1737360"/>
+            <a:ext cx="640080" cy="640080"/>
+          </a:xfrm>
+          <a:prstGeom prst="ellipse">
+            <a:avLst/>
+          </a:prstGeom>
+          <a:solidFill>
+            <a:schemeClr val="accent1"/>
+          </a:solidFill>
+          <a:ln/>
+        </p:spPr>
+      </p:sp>
+      <p:pic>
+        <p:nvPicPr>
+          <p:cNvPr id="11" name="Icon FaChartLine" descr="Symbol">    </p:cNvPr>
+          <p:cNvPicPr>
+            <a:picLocks noChangeAspect="1"/>
+          </p:cNvPicPr>
+          <p:nvPr/>
+        </p:nvPicPr>
+        <p:blipFill>
+          <a:blip r:embed="rId2"/>
+          <a:stretch>
+            <a:fillRect/>
+          </a:stretch>
+        </p:blipFill>
+        <p:spPr>
+          <a:xfrm>
+            <a:off x="4796942" y="1916582"/>
+            <a:ext cx="281635" cy="281635"/>
+          </a:xfrm>
+          <a:prstGeom prst="rect">
+            <a:avLst/>
+          </a:prstGeom>
+        </p:spPr>
+      </p:pic>
+      <p:sp>
+        <p:nvSpPr>
+          <p:cNvPr id="12" name="Text 7"/>
+          <p:cNvSpPr txBox="1"/>
+          <p:nvPr/>
+        </p:nvSpPr>
+        <p:spPr>
+          <a:xfrm>
+            <a:off x="5440680" y="1737360"/>
+            <a:ext cx="2103120" cy="640080"/>
+          </a:xfrm>
+          <a:prstGeom prst="rect">
+            <a:avLst/>
+          </a:prstGeom>
+          <a:noFill/>
+          <a:ln/>
+        </p:spPr>
+        <p:txBody>
+          <a:bodyPr wrap="square" lIns="0" tIns="0" rIns="0" bIns="0" rtlCol="0" anchor="ctr"/>
+          <a:lstStyle/>
+          <a:p>
+            <a:pPr indent="0" marL="0">
+              <a:buNone/>
+            </a:pPr>
+            <a:r>
+              <a:rPr lang="en-US" sz="2000" b="1" dirty="0">
+                <a:solidFill>
+                  <a:schemeClr val="tx2"/>
+                </a:solidFill>
+              </a:rPr>
+              <a:t>Mögliche Auswirkung</a:t>
+            </a:r>
+            <a:endParaRPr lang="en-US" sz="2000" dirty="0"/>
+          </a:p>
+        </p:txBody>
+      </p:sp>
+      <p:sp>
+        <p:nvSpPr>
+          <p:cNvPr id="13" name="Text 8"/>
+          <p:cNvSpPr txBox="1"/>
+          <p:nvPr/>
+        </p:nvSpPr>
+        <p:spPr>
+          <a:xfrm>
+            <a:off x="4617720" y="2651760"/>
+            <a:ext cx="2926080" cy="2194560"/>
+          </a:xfrm>
+          <a:prstGeom prst="rect">
+            <a:avLst/>
+          </a:prstGeom>
+          <a:noFill/>
+          <a:ln/>
+        </p:spPr>
+        <p:txBody>
+          <a:bodyPr wrap="square" lIns="0" tIns="0" rIns="0" bIns="0" rtlCol="0" anchor="t"/>
+          <a:lstStyle/>
+          <a:p>
+            <a:pPr indent="0" marL="0">
+              <a:spcAft>
+                <a:spcPts val="600"/>
+              </a:spcAft>
+              <a:buNone/>
+            </a:pPr>
+            <a:r>
+              <a:rPr lang="en-US" sz="1600" dirty="0">
+                <a:solidFill>
+                  <a:schemeClr val="tx1"/>
+                </a:solidFill>
+              </a:rPr>
+              <a:t>Wie hätte sich das auf Kosten, Absatz und Preis ausgewirkt?</a:t>
+            </a:r>
+            <a:endParaRPr lang="en-US" sz="1600" dirty="0"/>
+          </a:p>
+          <a:p>
+            <a:pPr indent="0" marL="0">
+              <a:spcAft>
+                <a:spcPts val="600"/>
+              </a:spcAft>
+              <a:buNone/>
+            </a:pPr>
+            <a:r>
+              <a:rPr lang="en-US" sz="1600" dirty="0">
+                <a:solidFill>
+                  <a:schemeClr val="tx1"/>
+                </a:solidFill>
+              </a:rPr>
+              <a:t>(später mit euren Zahlen untermauern)</a:t>
+            </a:r>
+            <a:endParaRPr lang="en-US" sz="1600" dirty="0"/>
+          </a:p>
+        </p:txBody>
+      </p:sp>
+      <p:sp>
+        <p:nvSpPr>
+          <p:cNvPr id="14" name="Karte Idee zur Spielerweiterung"/>
+          <p:cNvSpPr/>
+          <p:nvPr/>
+        </p:nvSpPr>
+        <p:spPr>
+          <a:xfrm>
+            <a:off x="8046720" y="1463040"/>
+            <a:ext cx="3474720" cy="3566160"/>
+          </a:xfrm>
+          <a:prstGeom prst="roundRect">
+            <a:avLst>
+              <a:gd name="adj" fmla="val 3158"/>
+            </a:avLst>
+          </a:prstGeom>
+          <a:solidFill>
+            <a:schemeClr val="bg2"/>
+          </a:solidFill>
+          <a:ln/>
+        </p:spPr>
+      </p:sp>
+      <p:sp>
+        <p:nvSpPr>
+          <p:cNvPr id="15" name="Icon-Kreis FaLightbulb"/>
+          <p:cNvSpPr/>
+          <p:nvPr/>
+        </p:nvSpPr>
+        <p:spPr>
+          <a:xfrm>
+            <a:off x="8321040" y="1737360"/>
+            <a:ext cx="640080" cy="640080"/>
+          </a:xfrm>
+          <a:prstGeom prst="ellipse">
+            <a:avLst/>
+          </a:prstGeom>
+          <a:solidFill>
+            <a:schemeClr val="accent2"/>
+          </a:solidFill>
+          <a:ln/>
+        </p:spPr>
+      </p:sp>
+      <p:pic>
+        <p:nvPicPr>
+          <p:cNvPr id="16" name="Icon FaLightbulb" descr="Symbol">    </p:cNvPr>
+          <p:cNvPicPr>
+            <a:picLocks noChangeAspect="1"/>
+          </p:cNvPicPr>
+          <p:nvPr/>
+        </p:nvPicPr>
+        <p:blipFill>
+          <a:blip r:embed="rId3"/>
+          <a:stretch>
+            <a:fillRect/>
+          </a:stretch>
+        </p:blipFill>
+        <p:spPr>
+          <a:xfrm>
+            <a:off x="8500262" y="1916582"/>
+            <a:ext cx="281635" cy="281635"/>
+          </a:xfrm>
+          <a:prstGeom prst="rect">
+            <a:avLst/>
+          </a:prstGeom>
+        </p:spPr>
+      </p:pic>
+      <p:sp>
+        <p:nvSpPr>
+          <p:cNvPr id="17" name="Text 11"/>
+          <p:cNvSpPr txBox="1"/>
+          <p:nvPr/>
+        </p:nvSpPr>
+        <p:spPr>
+          <a:xfrm>
+            <a:off x="9144000" y="1737360"/>
+            <a:ext cx="2103120" cy="640080"/>
+          </a:xfrm>
+          <a:prstGeom prst="rect">
+            <a:avLst/>
+          </a:prstGeom>
+          <a:noFill/>
+          <a:ln/>
+        </p:spPr>
+        <p:txBody>
+          <a:bodyPr wrap="square" lIns="0" tIns="0" rIns="0" bIns="0" rtlCol="0" anchor="ctr"/>
+          <a:lstStyle/>
+          <a:p>
+            <a:pPr indent="0" marL="0">
+              <a:buNone/>
+            </a:pPr>
+            <a:r>
+              <a:rPr lang="en-US" sz="2000" b="1" dirty="0">
+                <a:solidFill>
+                  <a:schemeClr val="tx2"/>
+                </a:solidFill>
+              </a:rPr>
+              <a:t>Idee zur Spielerweiterung</a:t>
+            </a:r>
+            <a:endParaRPr lang="en-US" sz="2000" dirty="0"/>
+          </a:p>
+        </p:txBody>
+      </p:sp>
+      <p:sp>
+        <p:nvSpPr>
+          <p:cNvPr id="18" name="Text 12"/>
+          <p:cNvSpPr txBox="1"/>
+          <p:nvPr/>
+        </p:nvSpPr>
+        <p:spPr>
+          <a:xfrm>
+            <a:off x="8321040" y="2651760"/>
+            <a:ext cx="2926080" cy="2194560"/>
+          </a:xfrm>
+          <a:prstGeom prst="rect">
+            <a:avLst/>
+          </a:prstGeom>
+          <a:noFill/>
+          <a:ln/>
+        </p:spPr>
+        <p:txBody>
+          <a:bodyPr wrap="square" lIns="0" tIns="0" rIns="0" bIns="0" rtlCol="0" anchor="t"/>
+          <a:lstStyle/>
+          <a:p>
+            <a:pPr indent="0" marL="0">
+              <a:spcAft>
+                <a:spcPts val="600"/>
+              </a:spcAft>
+              <a:buNone/>
+            </a:pPr>
+            <a:r>
+              <a:rPr lang="en-US" sz="1600" dirty="0">
+                <a:solidFill>
+                  <a:schemeClr val="tx1"/>
+                </a:solidFill>
+              </a:rPr>
+              <a:t>Konkreter, einfacher Vorschlag, z. B. eine zusätzliche Entscheidung pro Runde (Marketingbudget), ohne das Rechnen aufzublähen</a:t>
+            </a:r>
+            <a:endParaRPr lang="en-US" sz="1600" dirty="0"/>
+          </a:p>
+        </p:txBody>
+      </p:sp>
+      <p:sp>
+        <p:nvSpPr>
+          <p:cNvPr id="19" name="Platzhalter"/>
+          <p:cNvSpPr/>
+          <p:nvPr/>
+        </p:nvSpPr>
+        <p:spPr>
+          <a:xfrm>
+            <a:off x="640080" y="5257800"/>
+            <a:ext cx="10881360" cy="868680"/>
+          </a:xfrm>
+          <a:prstGeom prst="roundRect">
+            <a:avLst>
+              <a:gd name="adj" fmla="val 12632"/>
+            </a:avLst>
+          </a:prstGeom>
+          <a:solidFill>
+            <a:schemeClr val="bg2"/>
+          </a:solidFill>
+          <a:ln w="15875">
+            <a:solidFill>
+              <a:schemeClr val="accent5"/>
+            </a:solidFill>
+            <a:prstDash val="dash"/>
+          </a:ln>
+        </p:spPr>
+      </p:sp>
+      <p:sp>
+        <p:nvSpPr>
+          <p:cNvPr id="20" name="Text 14"/>
+          <p:cNvSpPr txBox="1"/>
+          <p:nvPr/>
+        </p:nvSpPr>
+        <p:spPr>
+          <a:xfrm>
+            <a:off x="868680" y="5257800"/>
+            <a:ext cx="10424160" cy="868680"/>
+          </a:xfrm>
+          <a:prstGeom prst="rect">
+            <a:avLst/>
+          </a:prstGeom>
+          <a:noFill/>
+          <a:ln/>
+        </p:spPr>
+        <p:txBody>
+          <a:bodyPr wrap="square" lIns="0" tIns="0" rIns="0" bIns="0" rtlCol="0" anchor="ctr"/>
+          <a:lstStyle/>
+          <a:p>
+            <a:pPr indent="0" marL="0">
+              <a:buNone/>
+            </a:pPr>
+            <a:r>
+              <a:rPr lang="en-US" sz="1600" b="1" dirty="0">
+                <a:solidFill>
+                  <a:schemeClr val="tx2"/>
+                </a:solidFill>
+              </a:rPr>
+              <a:t>Kernbotschaft</a:t>
+            </a:r>
+            <a:endParaRPr lang="en-US" sz="1600" dirty="0"/>
+          </a:p>
           <a:p>
             <a:pPr indent="0" marL="0">
               <a:buNone/>
@@ -2862,253 +3605,9 @@
                   <a:schemeClr val="tx1"/>
                 </a:solidFill>
               </a:rPr>
-              <a:t>– Mehrweg-Glas und Pfand</a:t>
+              <a:t>Was hätte die Gründungsidee im Spiel verändert? Ein Satz</a:t>
             </a:r>
-            <a:endParaRPr lang="en-US" sz="1400" dirty="0"/>
-          </a:p>
-          <a:p>
-            <a:pPr indent="0" marL="0">
-              <a:buNone/>
-            </a:pPr>
-            <a:r>
-              <a:rPr lang="en-US" sz="1400" dirty="0">
-                <a:solidFill>
-                  <a:schemeClr val="tx1"/>
-                </a:solidFill>
-              </a:rPr>
-              <a:t>– Social-Media-Marketing / Onlineshop</a:t>
-            </a:r>
-            <a:endParaRPr lang="en-US" sz="1400" dirty="0"/>
-          </a:p>
-          <a:p>
-            <a:pPr indent="0" marL="0">
-              <a:buNone/>
-            </a:pPr>
-            <a:r>
-              <a:rPr lang="en-US" sz="1400" dirty="0">
-                <a:solidFill>
-                  <a:schemeClr val="tx1"/>
-                </a:solidFill>
-              </a:rPr>
-              <a:t>– Nur eine Sorte, Tamarinde</a:t>
-            </a:r>
-            <a:endParaRPr lang="en-US" sz="1400" dirty="0"/>
-          </a:p>
-          <a:p>
-            <a:pPr indent="0" marL="0">
-              <a:buNone/>
-            </a:pPr>
-            <a:r>
-              <a:rPr lang="en-US" sz="1400" dirty="0">
-                <a:solidFill>
-                  <a:schemeClr val="tx1"/>
-                </a:solidFill>
-              </a:rPr>
-              <a:t>– Zielgruppe, Vertriebsweg</a:t>
-            </a:r>
-            <a:endParaRPr lang="en-US" sz="1400" dirty="0"/>
-          </a:p>
-        </p:txBody>
-      </p:sp>
-      <p:sp>
-        <p:nvSpPr>
-          <p:cNvPr id="7" name="Karte Mögliche Auswirkung"/>
-          <p:cNvSpPr/>
-          <p:nvPr/>
-        </p:nvSpPr>
-        <p:spPr>
-          <a:xfrm>
-            <a:off x="4343400" y="1463040"/>
-            <a:ext cx="3474720" cy="4480560"/>
-          </a:xfrm>
-          <a:prstGeom prst="roundRect">
-            <a:avLst>
-              <a:gd name="adj" fmla="val 3158"/>
-            </a:avLst>
-          </a:prstGeom>
-          <a:solidFill>
-            <a:schemeClr val="bg2"/>
-          </a:solidFill>
-          <a:ln/>
-        </p:spPr>
-      </p:sp>
-      <p:sp>
-        <p:nvSpPr>
-          <p:cNvPr id="8" name="Text 5"/>
-          <p:cNvSpPr txBox="1"/>
-          <p:nvPr/>
-        </p:nvSpPr>
-        <p:spPr>
-          <a:xfrm>
-            <a:off x="4572000" y="1600200"/>
-            <a:ext cx="3017520" cy="411480"/>
-          </a:xfrm>
-          <a:prstGeom prst="rect">
-            <a:avLst/>
-          </a:prstGeom>
-          <a:noFill/>
-          <a:ln/>
-        </p:spPr>
-        <p:txBody>
-          <a:bodyPr wrap="square" lIns="0" tIns="0" rIns="0" bIns="0" rtlCol="0" anchor="ctr"/>
-          <a:lstStyle/>
-          <a:p>
-            <a:pPr indent="0" marL="0">
-              <a:buNone/>
-            </a:pPr>
-            <a:r>
-              <a:rPr lang="en-US" sz="1800" b="1" dirty="0">
-                <a:solidFill>
-                  <a:schemeClr val="tx2"/>
-                </a:solidFill>
-              </a:rPr>
-              <a:t>Mögliche Auswirkung</a:t>
-            </a:r>
-            <a:endParaRPr lang="en-US" sz="1800" dirty="0"/>
-          </a:p>
-        </p:txBody>
-      </p:sp>
-      <p:sp>
-        <p:nvSpPr>
-          <p:cNvPr id="9" name="Text 6"/>
-          <p:cNvSpPr txBox="1"/>
-          <p:nvPr/>
-        </p:nvSpPr>
-        <p:spPr>
-          <a:xfrm>
-            <a:off x="4572000" y="2057400"/>
-            <a:ext cx="3017520" cy="3749040"/>
-          </a:xfrm>
-          <a:prstGeom prst="rect">
-            <a:avLst/>
-          </a:prstGeom>
-          <a:noFill/>
-          <a:ln/>
-        </p:spPr>
-        <p:txBody>
-          <a:bodyPr wrap="square" lIns="0" tIns="0" rIns="0" bIns="0" rtlCol="0" anchor="t"/>
-          <a:lstStyle/>
-          <a:p>
-            <a:pPr indent="0" marL="0">
-              <a:buNone/>
-            </a:pPr>
-            <a:r>
-              <a:rPr lang="en-US" sz="1400" dirty="0">
-                <a:solidFill>
-                  <a:schemeClr val="tx1"/>
-                </a:solidFill>
-              </a:rPr>
-              <a:t>Wie hätte sich das auf Kosten, Absatz und Preis ausgewirkt?</a:t>
-            </a:r>
-            <a:endParaRPr lang="en-US" sz="1400" dirty="0"/>
-          </a:p>
-          <a:p>
-            <a:pPr indent="0" marL="0">
-              <a:buNone/>
-            </a:pPr>
-            <a:r>
-              <a:rPr lang="en-US" sz="1400" dirty="0">
-                <a:solidFill>
-                  <a:schemeClr val="tx1"/>
-                </a:solidFill>
-              </a:rPr>
-              <a:t>(später mit euren Zahlen untermauern)</a:t>
-            </a:r>
-            <a:endParaRPr lang="en-US" sz="1400" dirty="0"/>
-          </a:p>
-        </p:txBody>
-      </p:sp>
-      <p:sp>
-        <p:nvSpPr>
-          <p:cNvPr id="10" name="Karte Idee zur Spielerweiterung"/>
-          <p:cNvSpPr/>
-          <p:nvPr/>
-        </p:nvSpPr>
-        <p:spPr>
-          <a:xfrm>
-            <a:off x="8046720" y="1463040"/>
-            <a:ext cx="3474720" cy="4480560"/>
-          </a:xfrm>
-          <a:prstGeom prst="roundRect">
-            <a:avLst>
-              <a:gd name="adj" fmla="val 3158"/>
-            </a:avLst>
-          </a:prstGeom>
-          <a:solidFill>
-            <a:schemeClr val="bg2"/>
-          </a:solidFill>
-          <a:ln/>
-        </p:spPr>
-      </p:sp>
-      <p:sp>
-        <p:nvSpPr>
-          <p:cNvPr id="11" name="Text 8"/>
-          <p:cNvSpPr txBox="1"/>
-          <p:nvPr/>
-        </p:nvSpPr>
-        <p:spPr>
-          <a:xfrm>
-            <a:off x="8275320" y="1600200"/>
-            <a:ext cx="3017520" cy="411480"/>
-          </a:xfrm>
-          <a:prstGeom prst="rect">
-            <a:avLst/>
-          </a:prstGeom>
-          <a:noFill/>
-          <a:ln/>
-        </p:spPr>
-        <p:txBody>
-          <a:bodyPr wrap="square" lIns="0" tIns="0" rIns="0" bIns="0" rtlCol="0" anchor="ctr"/>
-          <a:lstStyle/>
-          <a:p>
-            <a:pPr indent="0" marL="0">
-              <a:buNone/>
-            </a:pPr>
-            <a:r>
-              <a:rPr lang="en-US" sz="1800" b="1" dirty="0">
-                <a:solidFill>
-                  <a:schemeClr val="accent2"/>
-                </a:solidFill>
-              </a:rPr>
-              <a:t>Idee zur Spielerweiterung</a:t>
-            </a:r>
-            <a:endParaRPr lang="en-US" sz="1800" dirty="0"/>
-          </a:p>
-        </p:txBody>
-      </p:sp>
-      <p:sp>
-        <p:nvSpPr>
-          <p:cNvPr id="12" name="Text 9"/>
-          <p:cNvSpPr txBox="1"/>
-          <p:nvPr/>
-        </p:nvSpPr>
-        <p:spPr>
-          <a:xfrm>
-            <a:off x="8275320" y="2057400"/>
-            <a:ext cx="3017520" cy="3749040"/>
-          </a:xfrm>
-          <a:prstGeom prst="rect">
-            <a:avLst/>
-          </a:prstGeom>
-          <a:noFill/>
-          <a:ln/>
-        </p:spPr>
-        <p:txBody>
-          <a:bodyPr wrap="square" lIns="0" tIns="0" rIns="0" bIns="0" rtlCol="0" anchor="t"/>
-          <a:lstStyle/>
-          <a:p>
-            <a:pPr indent="0" marL="0">
-              <a:buNone/>
-            </a:pPr>
-            <a:r>
-              <a:rPr lang="en-US" sz="1400" dirty="0">
-                <a:solidFill>
-                  <a:schemeClr val="tx1"/>
-                </a:solidFill>
-              </a:rPr>
-              <a:t>Konkreter, einfacher Vorschlag, z. B. eine zusätzliche Entscheidung pro Runde (Marketingbudget), ohne das Rechnen aufzublähen</a:t>
-            </a:r>
-            <a:endParaRPr lang="en-US" sz="1400" dirty="0"/>
+            <a:endParaRPr lang="en-US" sz="1600" dirty="0"/>
           </a:p>
         </p:txBody>
       </p:sp>
@@ -3184,7 +3683,27 @@
       </p:grpSpPr>
       <p:sp>
         <p:nvSpPr>
-          <p:cNvPr id="2" name="Text 0"/>
+          <p:cNvPr id="2" name="Sonne"/>
+          <p:cNvSpPr/>
+          <p:nvPr/>
+        </p:nvSpPr>
+        <p:spPr>
+          <a:xfrm>
+            <a:off x="8686800" y="1737360"/>
+            <a:ext cx="2743200" cy="2743200"/>
+          </a:xfrm>
+          <a:prstGeom prst="ellipse">
+            <a:avLst/>
+          </a:prstGeom>
+          <a:solidFill>
+            <a:schemeClr val="accent2"/>
+          </a:solidFill>
+          <a:ln/>
+        </p:spPr>
+      </p:sp>
+      <p:sp>
+        <p:nvSpPr>
+          <p:cNvPr id="3" name="Text 1"/>
           <p:cNvSpPr txBox="1"/>
           <p:nvPr/>
         </p:nvSpPr>
@@ -3223,7 +3742,7 @@
       </p:sp>
       <p:sp>
         <p:nvSpPr>
-          <p:cNvPr id="3" name="Text 1"/>
+          <p:cNvPr id="4" name="Text 2"/>
           <p:cNvSpPr txBox="1"/>
           <p:nvPr/>
         </p:nvSpPr>
@@ -3259,7 +3778,7 @@
       </p:sp>
       <p:sp>
         <p:nvSpPr>
-          <p:cNvPr id="4" name="Text 2"/>
+          <p:cNvPr id="5" name="Text 3"/>
           <p:cNvSpPr txBox="1"/>
           <p:nvPr/>
         </p:nvSpPr>
@@ -3345,7 +3864,7 @@
               <a:buNone/>
             </a:pPr>
             <a:r>
-              <a:rPr lang="en-US" sz="3400" b="1" dirty="0">
+              <a:rPr lang="en-US" sz="3600" b="1" dirty="0">
                 <a:solidFill>
                   <a:schemeClr val="tx2"/>
                 </a:solidFill>
@@ -3355,24 +3874,102 @@
               </a:rPr>
               <a:t>Wer wir sind und warum wir gegründet haben</a:t>
             </a:r>
-            <a:endParaRPr lang="en-US" sz="3400" dirty="0"/>
+            <a:endParaRPr lang="en-US" sz="3600" dirty="0"/>
           </a:p>
         </p:txBody>
       </p:sp>
       <p:sp>
         <p:nvSpPr>
-          <p:cNvPr id="4" name="Karte Das Unternehmen"/>
+          <p:cNvPr id="4" name="Leitgedanke"/>
           <p:cNvSpPr/>
           <p:nvPr/>
         </p:nvSpPr>
         <p:spPr>
           <a:xfrm>
             <a:off x="640080" y="1463040"/>
-            <a:ext cx="3474720" cy="4480560"/>
+            <a:ext cx="4754880" cy="4480560"/>
           </a:xfrm>
           <a:prstGeom prst="roundRect">
             <a:avLst>
-              <a:gd name="adj" fmla="val 3158"/>
+              <a:gd name="adj" fmla="val 2449"/>
+            </a:avLst>
+          </a:prstGeom>
+          <a:solidFill>
+            <a:schemeClr val="accent1"/>
+          </a:solidFill>
+          <a:ln/>
+        </p:spPr>
+      </p:sp>
+      <p:sp>
+        <p:nvSpPr>
+          <p:cNvPr id="5" name="Text 2"/>
+          <p:cNvSpPr txBox="1"/>
+          <p:nvPr/>
+        </p:nvSpPr>
+        <p:spPr>
+          <a:xfrm>
+            <a:off x="1005840" y="1737360"/>
+            <a:ext cx="4023360" cy="3931920"/>
+          </a:xfrm>
+          <a:prstGeom prst="rect">
+            <a:avLst/>
+          </a:prstGeom>
+          <a:noFill/>
+          <a:ln/>
+        </p:spPr>
+        <p:txBody>
+          <a:bodyPr wrap="square" lIns="0" tIns="0" rIns="0" bIns="0" rtlCol="0" anchor="ctr"/>
+          <a:lstStyle/>
+          <a:p>
+            <a:pPr indent="0" marL="0">
+              <a:spcAft>
+                <a:spcPts val="1400"/>
+              </a:spcAft>
+              <a:buNone/>
+            </a:pPr>
+            <a:r>
+              <a:rPr lang="en-US" sz="3200" b="1" dirty="0">
+                <a:solidFill>
+                  <a:schemeClr val="bg1"/>
+                </a:solidFill>
+                <a:latin typeface="Cambria" pitchFamily="34" charset="0"/>
+                <a:ea typeface="Cambria" pitchFamily="34" charset="-122"/>
+                <a:cs typeface="Cambria" pitchFamily="34" charset="-120"/>
+              </a:rPr>
+              <a:t>Ein Getränk, dessen Rückseite man zu Ende lesen kann.</a:t>
+            </a:r>
+            <a:endParaRPr lang="en-US" sz="3200" dirty="0"/>
+          </a:p>
+          <a:p>
+            <a:pPr indent="0" marL="0">
+              <a:buNone/>
+            </a:pPr>
+            <a:r>
+              <a:rPr lang="en-US" sz="1600" dirty="0">
+                <a:solidFill>
+                  <a:schemeClr val="bg2"/>
+                </a:solidFill>
+              </a:rPr>
+              <a:t>Unsere einzige Vorgabe – daran haben wir alles andere gemessen.</a:t>
+            </a:r>
+            <a:endParaRPr lang="en-US" sz="3200" dirty="0"/>
+          </a:p>
+        </p:txBody>
+      </p:sp>
+      <p:sp>
+        <p:nvSpPr>
+          <p:cNvPr id="6" name="Karte Das Unternehmen"/>
+          <p:cNvSpPr/>
+          <p:nvPr/>
+        </p:nvSpPr>
+        <p:spPr>
+          <a:xfrm>
+            <a:off x="5669280" y="1463040"/>
+            <a:ext cx="5852160" cy="1371600"/>
+          </a:xfrm>
+          <a:prstGeom prst="roundRect">
+            <a:avLst>
+              <a:gd name="adj" fmla="val 8000"/>
             </a:avLst>
           </a:prstGeom>
           <a:solidFill>
@@ -3383,14 +3980,58 @@
       </p:sp>
       <p:sp>
         <p:nvSpPr>
-          <p:cNvPr id="5" name="Text 2"/>
+          <p:cNvPr id="7" name="Icon-Kreis FaBuilding"/>
+          <p:cNvSpPr/>
+          <p:nvPr/>
+        </p:nvSpPr>
+        <p:spPr>
+          <a:xfrm>
+            <a:off x="5943600" y="1828800"/>
+            <a:ext cx="640080" cy="640080"/>
+          </a:xfrm>
+          <a:prstGeom prst="ellipse">
+            <a:avLst/>
+          </a:prstGeom>
+          <a:solidFill>
+            <a:schemeClr val="accent1"/>
+          </a:solidFill>
+          <a:ln/>
+        </p:spPr>
+      </p:sp>
+      <p:pic>
+        <p:nvPicPr>
+          <p:cNvPr id="8" name="Icon FaBuilding" descr="Symbol">    </p:cNvPr>
+          <p:cNvPicPr>
+            <a:picLocks noChangeAspect="1"/>
+          </p:cNvPicPr>
+          <p:nvPr/>
+        </p:nvPicPr>
+        <p:blipFill>
+          <a:blip r:embed="rId1"/>
+          <a:stretch>
+            <a:fillRect/>
+          </a:stretch>
+        </p:blipFill>
+        <p:spPr>
+          <a:xfrm>
+            <a:off x="6122822" y="2008022"/>
+            <a:ext cx="281635" cy="281635"/>
+          </a:xfrm>
+          <a:prstGeom prst="rect">
+            <a:avLst/>
+          </a:prstGeom>
+        </p:spPr>
+      </p:pic>
+      <p:sp>
+        <p:nvSpPr>
+          <p:cNvPr id="9" name="Text 5"/>
           <p:cNvSpPr txBox="1"/>
           <p:nvPr/>
         </p:nvSpPr>
         <p:spPr>
           <a:xfrm>
-            <a:off x="868680" y="1600200"/>
-            <a:ext cx="3017520" cy="411480"/>
+            <a:off x="6812280" y="1463040"/>
+            <a:ext cx="4480560" cy="1371600"/>
           </a:xfrm>
           <a:prstGeom prst="rect">
             <a:avLst/>
@@ -3406,308 +4047,260 @@
               <a:buNone/>
             </a:pPr>
             <a:r>
-              <a:rPr lang="en-US" sz="1800" b="1" dirty="0">
+              <a:rPr lang="en-US" sz="2000" b="1" dirty="0">
                 <a:solidFill>
                   <a:schemeClr val="tx2"/>
                 </a:solidFill>
               </a:rPr>
               <a:t>Das Unternehmen</a:t>
             </a:r>
-            <a:endParaRPr lang="en-US" sz="1800" dirty="0"/>
-          </a:p>
-        </p:txBody>
-      </p:sp>
-      <p:sp>
-        <p:nvSpPr>
-          <p:cNvPr id="6" name="Text 3"/>
-          <p:cNvSpPr txBox="1"/>
-          <p:nvPr/>
-        </p:nvSpPr>
-        <p:spPr>
-          <a:xfrm>
-            <a:off x="868680" y="2057400"/>
-            <a:ext cx="3017520" cy="3749040"/>
-          </a:xfrm>
-          <a:prstGeom prst="rect">
-            <a:avLst/>
-          </a:prstGeom>
-          <a:noFill/>
-          <a:ln/>
-        </p:spPr>
-        <p:txBody>
-          <a:bodyPr wrap="square" lIns="0" tIns="0" rIns="0" bIns="0" rtlCol="0" anchor="t"/>
-          <a:lstStyle/>
+            <a:endParaRPr lang="en-US" sz="2000" dirty="0"/>
+          </a:p>
           <a:p>
             <a:pPr indent="0" marL="0">
               <a:buNone/>
             </a:pPr>
             <a:r>
-              <a:rPr lang="en-US" sz="1400" dirty="0">
+              <a:rPr lang="en-US" sz="1600" dirty="0">
                 <a:solidFill>
                   <a:schemeClr val="tx1"/>
                 </a:solidFill>
               </a:rPr>
-              <a:t>Elbharz Getränke GbR, Hamburg</a:t>
+              <a:t>Elbharz Getränke GbR, Hamburg, 4 Gesellschafter. Produkt: Primatenbrause (Tamarinde-Limette)</a:t>
             </a:r>
-            <a:endParaRPr lang="en-US" sz="1400" dirty="0"/>
-          </a:p>
+            <a:endParaRPr lang="en-US" sz="2000" dirty="0"/>
+          </a:p>
+        </p:txBody>
+      </p:sp>
+      <p:sp>
+        <p:nvSpPr>
+          <p:cNvPr id="10" name="Karte Die Zielgruppe"/>
+          <p:cNvSpPr/>
+          <p:nvPr/>
+        </p:nvSpPr>
+        <p:spPr>
+          <a:xfrm>
+            <a:off x="5669280" y="3017520"/>
+            <a:ext cx="5852160" cy="1371600"/>
+          </a:xfrm>
+          <a:prstGeom prst="roundRect">
+            <a:avLst>
+              <a:gd name="adj" fmla="val 8000"/>
+            </a:avLst>
+          </a:prstGeom>
+          <a:solidFill>
+            <a:schemeClr val="bg2"/>
+          </a:solidFill>
+          <a:ln/>
+        </p:spPr>
+      </p:sp>
+      <p:sp>
+        <p:nvSpPr>
+          <p:cNvPr id="11" name="Icon-Kreis FaBullseye"/>
+          <p:cNvSpPr/>
+          <p:nvPr/>
+        </p:nvSpPr>
+        <p:spPr>
+          <a:xfrm>
+            <a:off x="5943600" y="3383280"/>
+            <a:ext cx="640080" cy="640080"/>
+          </a:xfrm>
+          <a:prstGeom prst="ellipse">
+            <a:avLst/>
+          </a:prstGeom>
+          <a:solidFill>
+            <a:schemeClr val="accent2"/>
+          </a:solidFill>
+          <a:ln/>
+        </p:spPr>
+      </p:sp>
+      <p:pic>
+        <p:nvPicPr>
+          <p:cNvPr id="12" name="Icon FaBullseye" descr="Symbol">    </p:cNvPr>
+          <p:cNvPicPr>
+            <a:picLocks noChangeAspect="1"/>
+          </p:cNvPicPr>
+          <p:nvPr/>
+        </p:nvPicPr>
+        <p:blipFill>
+          <a:blip r:embed="rId2"/>
+          <a:stretch>
+            <a:fillRect/>
+          </a:stretch>
+        </p:blipFill>
+        <p:spPr>
+          <a:xfrm>
+            <a:off x="6122822" y="3562502"/>
+            <a:ext cx="281635" cy="281635"/>
+          </a:xfrm>
+          <a:prstGeom prst="rect">
+            <a:avLst/>
+          </a:prstGeom>
+        </p:spPr>
+      </p:pic>
+      <p:sp>
+        <p:nvSpPr>
+          <p:cNvPr id="13" name="Text 8"/>
+          <p:cNvSpPr txBox="1"/>
+          <p:nvPr/>
+        </p:nvSpPr>
+        <p:spPr>
+          <a:xfrm>
+            <a:off x="6812280" y="3017520"/>
+            <a:ext cx="4480560" cy="1371600"/>
+          </a:xfrm>
+          <a:prstGeom prst="rect">
+            <a:avLst/>
+          </a:prstGeom>
+          <a:noFill/>
+          <a:ln/>
+        </p:spPr>
+        <p:txBody>
+          <a:bodyPr wrap="square" lIns="0" tIns="0" rIns="0" bIns="0" rtlCol="0" anchor="ctr"/>
+          <a:lstStyle/>
           <a:p>
             <a:pPr indent="0" marL="0">
               <a:buNone/>
             </a:pPr>
             <a:r>
-              <a:rPr lang="en-US" sz="1400" dirty="0">
+              <a:rPr lang="en-US" sz="2000" b="1" dirty="0">
+                <a:solidFill>
+                  <a:schemeClr val="tx2"/>
+                </a:solidFill>
+              </a:rPr>
+              <a:t>Die Zielgruppe</a:t>
+            </a:r>
+            <a:endParaRPr lang="en-US" sz="2000" dirty="0"/>
+          </a:p>
+          <a:p>
+            <a:pPr indent="0" marL="0">
+              <a:buNone/>
+            </a:pPr>
+            <a:r>
+              <a:rPr lang="en-US" sz="1600" dirty="0">
                 <a:solidFill>
                   <a:schemeClr val="tx1"/>
                 </a:solidFill>
               </a:rPr>
-              <a:t>4 Gesellschafter</a:t>
+              <a:t>16–25 Jahre, liest Etiketten aus Misstrauen – Slogan: „Was dein Körper schon immer wollte.“</a:t>
             </a:r>
-            <a:endParaRPr lang="en-US" sz="1400" dirty="0"/>
-          </a:p>
+            <a:endParaRPr lang="en-US" sz="2000" dirty="0"/>
+          </a:p>
+        </p:txBody>
+      </p:sp>
+      <p:sp>
+        <p:nvSpPr>
+          <p:cNvPr id="14" name="Karte Der Vertrieb"/>
+          <p:cNvSpPr/>
+          <p:nvPr/>
+        </p:nvSpPr>
+        <p:spPr>
+          <a:xfrm>
+            <a:off x="5669280" y="4572000"/>
+            <a:ext cx="5852160" cy="1371600"/>
+          </a:xfrm>
+          <a:prstGeom prst="roundRect">
+            <a:avLst>
+              <a:gd name="adj" fmla="val 8000"/>
+            </a:avLst>
+          </a:prstGeom>
+          <a:solidFill>
+            <a:schemeClr val="bg2"/>
+          </a:solidFill>
+          <a:ln/>
+        </p:spPr>
+      </p:sp>
+      <p:sp>
+        <p:nvSpPr>
+          <p:cNvPr id="15" name="Icon-Kreis FaStore"/>
+          <p:cNvSpPr/>
+          <p:nvPr/>
+        </p:nvSpPr>
+        <p:spPr>
+          <a:xfrm>
+            <a:off x="5943600" y="4937760"/>
+            <a:ext cx="640080" cy="640080"/>
+          </a:xfrm>
+          <a:prstGeom prst="ellipse">
+            <a:avLst/>
+          </a:prstGeom>
+          <a:solidFill>
+            <a:schemeClr val="accent3"/>
+          </a:solidFill>
+          <a:ln/>
+        </p:spPr>
+      </p:sp>
+      <p:pic>
+        <p:nvPicPr>
+          <p:cNvPr id="16" name="Icon FaStore" descr="Symbol">    </p:cNvPr>
+          <p:cNvPicPr>
+            <a:picLocks noChangeAspect="1"/>
+          </p:cNvPicPr>
+          <p:nvPr/>
+        </p:nvPicPr>
+        <p:blipFill>
+          <a:blip r:embed="rId3"/>
+          <a:stretch>
+            <a:fillRect/>
+          </a:stretch>
+        </p:blipFill>
+        <p:spPr>
+          <a:xfrm>
+            <a:off x="6122822" y="5116982"/>
+            <a:ext cx="281635" cy="281635"/>
+          </a:xfrm>
+          <a:prstGeom prst="rect">
+            <a:avLst/>
+          </a:prstGeom>
+        </p:spPr>
+      </p:pic>
+      <p:sp>
+        <p:nvSpPr>
+          <p:cNvPr id="17" name="Text 11"/>
+          <p:cNvSpPr txBox="1"/>
+          <p:nvPr/>
+        </p:nvSpPr>
+        <p:spPr>
+          <a:xfrm>
+            <a:off x="6812280" y="4572000"/>
+            <a:ext cx="4480560" cy="1371600"/>
+          </a:xfrm>
+          <a:prstGeom prst="rect">
+            <a:avLst/>
+          </a:prstGeom>
+          <a:noFill/>
+          <a:ln/>
+        </p:spPr>
+        <p:txBody>
+          <a:bodyPr wrap="square" lIns="0" tIns="0" rIns="0" bIns="0" rtlCol="0" anchor="ctr"/>
+          <a:lstStyle/>
           <a:p>
             <a:pPr indent="0" marL="0">
               <a:buNone/>
             </a:pPr>
             <a:r>
-              <a:rPr lang="en-US" sz="1400" dirty="0">
+              <a:rPr lang="en-US" sz="2000" b="1" dirty="0">
+                <a:solidFill>
+                  <a:schemeClr val="tx2"/>
+                </a:solidFill>
+              </a:rPr>
+              <a:t>Der Vertrieb</a:t>
+            </a:r>
+            <a:endParaRPr lang="en-US" sz="2000" dirty="0"/>
+          </a:p>
+          <a:p>
+            <a:pPr indent="0" marL="0">
+              <a:buNone/>
+            </a:pPr>
+            <a:r>
+              <a:rPr lang="en-US" sz="1600" dirty="0">
                 <a:solidFill>
                   <a:schemeClr val="tx1"/>
                 </a:solidFill>
               </a:rPr>
-              <a:t>Produkt: Primatenbrause (Tamarinde-Limette)</a:t>
+              <a:t>Onlineshop und Social Media, dann regionaler Handel, dazu Messen und Märkte</a:t>
             </a:r>
-            <a:endParaRPr lang="en-US" sz="1400" dirty="0"/>
-          </a:p>
-          <a:p>
-            <a:pPr indent="0" marL="0">
-              <a:buNone/>
-            </a:pPr>
-            <a:r>
-              <a:rPr lang="en-US" sz="1400" dirty="0">
-                <a:solidFill>
-                  <a:schemeClr val="tx1"/>
-                </a:solidFill>
-              </a:rPr>
-              <a:t>Slogan: „Was dein Körper schon immer wollte.“</a:t>
-            </a:r>
-            <a:endParaRPr lang="en-US" sz="1400" dirty="0"/>
-          </a:p>
-        </p:txBody>
-      </p:sp>
-      <p:sp>
-        <p:nvSpPr>
-          <p:cNvPr id="7" name="Karte Die Gründungsidee"/>
-          <p:cNvSpPr/>
-          <p:nvPr/>
-        </p:nvSpPr>
-        <p:spPr>
-          <a:xfrm>
-            <a:off x="4343400" y="1463040"/>
-            <a:ext cx="3474720" cy="4480560"/>
-          </a:xfrm>
-          <a:prstGeom prst="roundRect">
-            <a:avLst>
-              <a:gd name="adj" fmla="val 3158"/>
-            </a:avLst>
-          </a:prstGeom>
-          <a:solidFill>
-            <a:schemeClr val="bg2"/>
-          </a:solidFill>
-          <a:ln/>
-        </p:spPr>
-      </p:sp>
-      <p:sp>
-        <p:nvSpPr>
-          <p:cNvPr id="8" name="Text 5"/>
-          <p:cNvSpPr txBox="1"/>
-          <p:nvPr/>
-        </p:nvSpPr>
-        <p:spPr>
-          <a:xfrm>
-            <a:off x="4572000" y="1600200"/>
-            <a:ext cx="3017520" cy="411480"/>
-          </a:xfrm>
-          <a:prstGeom prst="rect">
-            <a:avLst/>
-          </a:prstGeom>
-          <a:noFill/>
-          <a:ln/>
-        </p:spPr>
-        <p:txBody>
-          <a:bodyPr wrap="square" lIns="0" tIns="0" rIns="0" bIns="0" rtlCol="0" anchor="ctr"/>
-          <a:lstStyle/>
-          <a:p>
-            <a:pPr indent="0" marL="0">
-              <a:buNone/>
-            </a:pPr>
-            <a:r>
-              <a:rPr lang="en-US" sz="1800" b="1" dirty="0">
-                <a:solidFill>
-                  <a:schemeClr val="tx2"/>
-                </a:solidFill>
-              </a:rPr>
-              <a:t>Die Gründungsidee</a:t>
-            </a:r>
-            <a:endParaRPr lang="en-US" sz="1800" dirty="0"/>
-          </a:p>
-        </p:txBody>
-      </p:sp>
-      <p:sp>
-        <p:nvSpPr>
-          <p:cNvPr id="9" name="Text 6"/>
-          <p:cNvSpPr txBox="1"/>
-          <p:nvPr/>
-        </p:nvSpPr>
-        <p:spPr>
-          <a:xfrm>
-            <a:off x="4572000" y="2057400"/>
-            <a:ext cx="3017520" cy="3749040"/>
-          </a:xfrm>
-          <a:prstGeom prst="rect">
-            <a:avLst/>
-          </a:prstGeom>
-          <a:noFill/>
-          <a:ln/>
-        </p:spPr>
-        <p:txBody>
-          <a:bodyPr wrap="square" lIns="0" tIns="0" rIns="0" bIns="0" rtlCol="0" anchor="t"/>
-          <a:lstStyle/>
-          <a:p>
-            <a:pPr indent="0" marL="0">
-              <a:buNone/>
-            </a:pPr>
-            <a:r>
-              <a:rPr lang="en-US" sz="1400" dirty="0">
-                <a:solidFill>
-                  <a:schemeClr val="tx1"/>
-                </a:solidFill>
-              </a:rPr>
-              <a:t>Ein Getränk, dessen Rückseite man zu Ende lesen kann.</a:t>
-            </a:r>
-            <a:endParaRPr lang="en-US" sz="1400" dirty="0"/>
-          </a:p>
-          <a:p>
-            <a:pPr indent="0" marL="0">
-              <a:buNone/>
-            </a:pPr>
-            <a:r>
-              <a:rPr lang="en-US" sz="1400" dirty="0">
-                <a:solidFill>
-                  <a:schemeClr val="tx1"/>
-                </a:solidFill>
-              </a:rPr>
-              <a:t>Kurze, bekannte Zutaten, nichts versprechen, was das Etikett nicht belegt.</a:t>
-            </a:r>
-            <a:endParaRPr lang="en-US" sz="1400" dirty="0"/>
-          </a:p>
-        </p:txBody>
-      </p:sp>
-      <p:sp>
-        <p:nvSpPr>
-          <p:cNvPr id="10" name="Karte Zielgruppe &amp; Vertrieb"/>
-          <p:cNvSpPr/>
-          <p:nvPr/>
-        </p:nvSpPr>
-        <p:spPr>
-          <a:xfrm>
-            <a:off x="8046720" y="1463040"/>
-            <a:ext cx="3474720" cy="4480560"/>
-          </a:xfrm>
-          <a:prstGeom prst="roundRect">
-            <a:avLst>
-              <a:gd name="adj" fmla="val 3158"/>
-            </a:avLst>
-          </a:prstGeom>
-          <a:solidFill>
-            <a:schemeClr val="bg2"/>
-          </a:solidFill>
-          <a:ln/>
-        </p:spPr>
-      </p:sp>
-      <p:sp>
-        <p:nvSpPr>
-          <p:cNvPr id="11" name="Text 8"/>
-          <p:cNvSpPr txBox="1"/>
-          <p:nvPr/>
-        </p:nvSpPr>
-        <p:spPr>
-          <a:xfrm>
-            <a:off x="8275320" y="1600200"/>
-            <a:ext cx="3017520" cy="411480"/>
-          </a:xfrm>
-          <a:prstGeom prst="rect">
-            <a:avLst/>
-          </a:prstGeom>
-          <a:noFill/>
-          <a:ln/>
-        </p:spPr>
-        <p:txBody>
-          <a:bodyPr wrap="square" lIns="0" tIns="0" rIns="0" bIns="0" rtlCol="0" anchor="ctr"/>
-          <a:lstStyle/>
-          <a:p>
-            <a:pPr indent="0" marL="0">
-              <a:buNone/>
-            </a:pPr>
-            <a:r>
-              <a:rPr lang="en-US" sz="1800" b="1" dirty="0">
-                <a:solidFill>
-                  <a:schemeClr val="tx2"/>
-                </a:solidFill>
-              </a:rPr>
-              <a:t>Zielgruppe &amp; Vertrieb</a:t>
-            </a:r>
-            <a:endParaRPr lang="en-US" sz="1800" dirty="0"/>
-          </a:p>
-        </p:txBody>
-      </p:sp>
-      <p:sp>
-        <p:nvSpPr>
-          <p:cNvPr id="12" name="Text 9"/>
-          <p:cNvSpPr txBox="1"/>
-          <p:nvPr/>
-        </p:nvSpPr>
-        <p:spPr>
-          <a:xfrm>
-            <a:off x="8275320" y="2057400"/>
-            <a:ext cx="3017520" cy="3749040"/>
-          </a:xfrm>
-          <a:prstGeom prst="rect">
-            <a:avLst/>
-          </a:prstGeom>
-          <a:noFill/>
-          <a:ln/>
-        </p:spPr>
-        <p:txBody>
-          <a:bodyPr wrap="square" lIns="0" tIns="0" rIns="0" bIns="0" rtlCol="0" anchor="t"/>
-          <a:lstStyle/>
-          <a:p>
-            <a:pPr indent="0" marL="0">
-              <a:buNone/>
-            </a:pPr>
-            <a:r>
-              <a:rPr lang="en-US" sz="1400" dirty="0">
-                <a:solidFill>
-                  <a:schemeClr val="tx1"/>
-                </a:solidFill>
-              </a:rPr>
-              <a:t>16–25 Jahre, Etiketten-Leser</a:t>
-            </a:r>
-            <a:endParaRPr lang="en-US" sz="1400" dirty="0"/>
-          </a:p>
-          <a:p>
-            <a:pPr indent="0" marL="0">
-              <a:buNone/>
-            </a:pPr>
-            <a:r>
-              <a:rPr lang="en-US" sz="1400" dirty="0">
-                <a:solidFill>
-                  <a:schemeClr val="tx1"/>
-                </a:solidFill>
-              </a:rPr>
-              <a:t>Onlineshop + Social Media, regionaler Handel, Messen und Märkte</a:t>
-            </a:r>
-            <a:endParaRPr lang="en-US" sz="1400" dirty="0"/>
+            <a:endParaRPr lang="en-US" sz="2000" dirty="0"/>
           </a:p>
         </p:txBody>
       </p:sp>
@@ -3808,7 +4401,7 @@
               <a:buNone/>
             </a:pPr>
             <a:r>
-              <a:rPr lang="en-US" sz="3400" b="1" dirty="0">
+              <a:rPr lang="en-US" sz="3600" b="1" dirty="0">
                 <a:solidFill>
                   <a:schemeClr val="tx2"/>
                 </a:solidFill>
@@ -3818,7 +4411,7 @@
               </a:rPr>
               <a:t>Nachhaltigkeit von Anfang an</a:t>
             </a:r>
-            <a:endParaRPr lang="en-US" sz="3400" dirty="0"/>
+            <a:endParaRPr lang="en-US" sz="3600" dirty="0"/>
           </a:p>
         </p:txBody>
       </p:sp>
@@ -3846,14 +4439,58 @@
       </p:sp>
       <p:sp>
         <p:nvSpPr>
-          <p:cNvPr id="5" name="Text 2"/>
+          <p:cNvPr id="5" name="Icon-Kreis FaRecycle"/>
+          <p:cNvSpPr/>
+          <p:nvPr/>
+        </p:nvSpPr>
+        <p:spPr>
+          <a:xfrm>
+            <a:off x="914400" y="1737360"/>
+            <a:ext cx="640080" cy="640080"/>
+          </a:xfrm>
+          <a:prstGeom prst="ellipse">
+            <a:avLst/>
+          </a:prstGeom>
+          <a:solidFill>
+            <a:schemeClr val="accent3"/>
+          </a:solidFill>
+          <a:ln/>
+        </p:spPr>
+      </p:sp>
+      <p:pic>
+        <p:nvPicPr>
+          <p:cNvPr id="6" name="Icon FaRecycle" descr="Symbol">    </p:cNvPr>
+          <p:cNvPicPr>
+            <a:picLocks noChangeAspect="1"/>
+          </p:cNvPicPr>
+          <p:nvPr/>
+        </p:nvPicPr>
+        <p:blipFill>
+          <a:blip r:embed="rId1"/>
+          <a:stretch>
+            <a:fillRect/>
+          </a:stretch>
+        </p:blipFill>
+        <p:spPr>
+          <a:xfrm>
+            <a:off x="1093622" y="1916582"/>
+            <a:ext cx="281635" cy="281635"/>
+          </a:xfrm>
+          <a:prstGeom prst="rect">
+            <a:avLst/>
+          </a:prstGeom>
+        </p:spPr>
+      </p:pic>
+      <p:sp>
+        <p:nvSpPr>
+          <p:cNvPr id="7" name="Text 3"/>
           <p:cNvSpPr txBox="1"/>
           <p:nvPr/>
         </p:nvSpPr>
         <p:spPr>
           <a:xfrm>
-            <a:off x="868680" y="1600200"/>
-            <a:ext cx="3017520" cy="411480"/>
+            <a:off x="1737360" y="1737360"/>
+            <a:ext cx="2103120" cy="640080"/>
           </a:xfrm>
           <a:prstGeom prst="rect">
             <a:avLst/>
@@ -3869,27 +4506,27 @@
               <a:buNone/>
             </a:pPr>
             <a:r>
-              <a:rPr lang="en-US" sz="1800" b="1" dirty="0">
+              <a:rPr lang="en-US" sz="2000" b="1" dirty="0">
                 <a:solidFill>
-                  <a:schemeClr val="accent3"/>
+                  <a:schemeClr val="tx2"/>
                 </a:solidFill>
               </a:rPr>
               <a:t>Mehrweg-Glas</a:t>
             </a:r>
-            <a:endParaRPr lang="en-US" sz="1800" dirty="0"/>
+            <a:endParaRPr lang="en-US" sz="2000" dirty="0"/>
           </a:p>
         </p:txBody>
       </p:sp>
       <p:sp>
         <p:nvSpPr>
-          <p:cNvPr id="6" name="Text 3"/>
+          <p:cNvPr id="8" name="Text 4"/>
           <p:cNvSpPr txBox="1"/>
           <p:nvPr/>
         </p:nvSpPr>
         <p:spPr>
           <a:xfrm>
-            <a:off x="868680" y="2057400"/>
-            <a:ext cx="3017520" cy="2194560"/>
+            <a:off x="914400" y="2651760"/>
+            <a:ext cx="2926080" cy="1554480"/>
           </a:xfrm>
           <a:prstGeom prst="rect">
             <a:avLst/>
@@ -3902,23 +4539,26 @@
           <a:lstStyle/>
           <a:p>
             <a:pPr indent="0" marL="0">
+              <a:spcAft>
+                <a:spcPts val="600"/>
+              </a:spcAft>
               <a:buNone/>
             </a:pPr>
             <a:r>
-              <a:rPr lang="en-US" sz="1400" dirty="0">
+              <a:rPr lang="en-US" sz="1600" dirty="0">
                 <a:solidFill>
                   <a:schemeClr val="tx1"/>
                 </a:solidFill>
               </a:rPr>
               <a:t>Pfandsystem statt Einweg</a:t>
             </a:r>
-            <a:endParaRPr lang="en-US" sz="1400" dirty="0"/>
+            <a:endParaRPr lang="en-US" sz="1600" dirty="0"/>
           </a:p>
         </p:txBody>
       </p:sp>
       <p:sp>
         <p:nvSpPr>
-          <p:cNvPr id="7" name="Karte Regional"/>
+          <p:cNvPr id="9" name="Karte Regional"/>
           <p:cNvSpPr/>
           <p:nvPr/>
         </p:nvSpPr>
@@ -3940,14 +4580,58 @@
       </p:sp>
       <p:sp>
         <p:nvSpPr>
-          <p:cNvPr id="8" name="Text 5"/>
+          <p:cNvPr id="10" name="Icon-Kreis FaMapMarkerAlt"/>
+          <p:cNvSpPr/>
+          <p:nvPr/>
+        </p:nvSpPr>
+        <p:spPr>
+          <a:xfrm>
+            <a:off x="4617720" y="1737360"/>
+            <a:ext cx="640080" cy="640080"/>
+          </a:xfrm>
+          <a:prstGeom prst="ellipse">
+            <a:avLst/>
+          </a:prstGeom>
+          <a:solidFill>
+            <a:schemeClr val="accent3"/>
+          </a:solidFill>
+          <a:ln/>
+        </p:spPr>
+      </p:sp>
+      <p:pic>
+        <p:nvPicPr>
+          <p:cNvPr id="11" name="Icon FaMapMarkerAlt" descr="Symbol">    </p:cNvPr>
+          <p:cNvPicPr>
+            <a:picLocks noChangeAspect="1"/>
+          </p:cNvPicPr>
+          <p:nvPr/>
+        </p:nvPicPr>
+        <p:blipFill>
+          <a:blip r:embed="rId2"/>
+          <a:stretch>
+            <a:fillRect/>
+          </a:stretch>
+        </p:blipFill>
+        <p:spPr>
+          <a:xfrm>
+            <a:off x="4796942" y="1916582"/>
+            <a:ext cx="281635" cy="281635"/>
+          </a:xfrm>
+          <a:prstGeom prst="rect">
+            <a:avLst/>
+          </a:prstGeom>
+        </p:spPr>
+      </p:pic>
+      <p:sp>
+        <p:nvSpPr>
+          <p:cNvPr id="12" name="Text 7"/>
           <p:cNvSpPr txBox="1"/>
           <p:nvPr/>
         </p:nvSpPr>
         <p:spPr>
           <a:xfrm>
-            <a:off x="4572000" y="1600200"/>
-            <a:ext cx="3017520" cy="411480"/>
+            <a:off x="5440680" y="1737360"/>
+            <a:ext cx="2103120" cy="640080"/>
           </a:xfrm>
           <a:prstGeom prst="rect">
             <a:avLst/>
@@ -3963,27 +4647,27 @@
               <a:buNone/>
             </a:pPr>
             <a:r>
-              <a:rPr lang="en-US" sz="1800" b="1" dirty="0">
+              <a:rPr lang="en-US" sz="2000" b="1" dirty="0">
                 <a:solidFill>
-                  <a:schemeClr val="accent3"/>
+                  <a:schemeClr val="tx2"/>
                 </a:solidFill>
               </a:rPr>
               <a:t>Regional</a:t>
             </a:r>
-            <a:endParaRPr lang="en-US" sz="1800" dirty="0"/>
+            <a:endParaRPr lang="en-US" sz="2000" dirty="0"/>
           </a:p>
         </p:txBody>
       </p:sp>
       <p:sp>
         <p:nvSpPr>
-          <p:cNvPr id="9" name="Text 6"/>
+          <p:cNvPr id="13" name="Text 8"/>
           <p:cNvSpPr txBox="1"/>
           <p:nvPr/>
         </p:nvSpPr>
         <p:spPr>
           <a:xfrm>
-            <a:off x="4572000" y="2057400"/>
-            <a:ext cx="3017520" cy="2194560"/>
+            <a:off x="4617720" y="2651760"/>
+            <a:ext cx="2926080" cy="1554480"/>
           </a:xfrm>
           <a:prstGeom prst="rect">
             <a:avLst/>
@@ -3996,23 +4680,26 @@
           <a:lstStyle/>
           <a:p>
             <a:pPr indent="0" marL="0">
+              <a:spcAft>
+                <a:spcPts val="600"/>
+              </a:spcAft>
               <a:buNone/>
             </a:pPr>
             <a:r>
-              <a:rPr lang="en-US" sz="1400" dirty="0">
+              <a:rPr lang="en-US" sz="1600" dirty="0">
                 <a:solidFill>
                   <a:schemeClr val="tx1"/>
                 </a:solidFill>
               </a:rPr>
               <a:t>Hier gebraut, hier abgefüllt – kurze Wege, damit Mehrweg ökologisch wirklich besser ist</a:t>
             </a:r>
-            <a:endParaRPr lang="en-US" sz="1400" dirty="0"/>
+            <a:endParaRPr lang="en-US" sz="1600" dirty="0"/>
           </a:p>
         </p:txBody>
       </p:sp>
       <p:sp>
         <p:nvSpPr>
-          <p:cNvPr id="10" name="Karte Eine Sorte"/>
+          <p:cNvPr id="14" name="Karte Eine Sorte"/>
           <p:cNvSpPr/>
           <p:nvPr/>
         </p:nvSpPr>
@@ -4034,14 +4721,58 @@
       </p:sp>
       <p:sp>
         <p:nvSpPr>
-          <p:cNvPr id="11" name="Text 8"/>
+          <p:cNvPr id="15" name="Icon-Kreis FaLeaf"/>
+          <p:cNvSpPr/>
+          <p:nvPr/>
+        </p:nvSpPr>
+        <p:spPr>
+          <a:xfrm>
+            <a:off x="8321040" y="1737360"/>
+            <a:ext cx="640080" cy="640080"/>
+          </a:xfrm>
+          <a:prstGeom prst="ellipse">
+            <a:avLst/>
+          </a:prstGeom>
+          <a:solidFill>
+            <a:schemeClr val="accent3"/>
+          </a:solidFill>
+          <a:ln/>
+        </p:spPr>
+      </p:sp>
+      <p:pic>
+        <p:nvPicPr>
+          <p:cNvPr id="16" name="Icon FaLeaf" descr="Symbol">    </p:cNvPr>
+          <p:cNvPicPr>
+            <a:picLocks noChangeAspect="1"/>
+          </p:cNvPicPr>
+          <p:nvPr/>
+        </p:nvPicPr>
+        <p:blipFill>
+          <a:blip r:embed="rId3"/>
+          <a:stretch>
+            <a:fillRect/>
+          </a:stretch>
+        </p:blipFill>
+        <p:spPr>
+          <a:xfrm>
+            <a:off x="8500262" y="1916582"/>
+            <a:ext cx="281635" cy="281635"/>
+          </a:xfrm>
+          <a:prstGeom prst="rect">
+            <a:avLst/>
+          </a:prstGeom>
+        </p:spPr>
+      </p:pic>
+      <p:sp>
+        <p:nvSpPr>
+          <p:cNvPr id="17" name="Text 11"/>
           <p:cNvSpPr txBox="1"/>
           <p:nvPr/>
         </p:nvSpPr>
         <p:spPr>
           <a:xfrm>
-            <a:off x="8275320" y="1600200"/>
-            <a:ext cx="3017520" cy="411480"/>
+            <a:off x="9144000" y="1737360"/>
+            <a:ext cx="2103120" cy="640080"/>
           </a:xfrm>
           <a:prstGeom prst="rect">
             <a:avLst/>
@@ -4057,27 +4788,27 @@
               <a:buNone/>
             </a:pPr>
             <a:r>
-              <a:rPr lang="en-US" sz="1800" b="1" dirty="0">
+              <a:rPr lang="en-US" sz="2000" b="1" dirty="0">
                 <a:solidFill>
-                  <a:schemeClr val="accent3"/>
+                  <a:schemeClr val="tx2"/>
                 </a:solidFill>
               </a:rPr>
               <a:t>Eine Sorte</a:t>
             </a:r>
-            <a:endParaRPr lang="en-US" sz="1800" dirty="0"/>
+            <a:endParaRPr lang="en-US" sz="2000" dirty="0"/>
           </a:p>
         </p:txBody>
       </p:sp>
       <p:sp>
         <p:nvSpPr>
-          <p:cNvPr id="12" name="Text 9"/>
+          <p:cNvPr id="18" name="Text 12"/>
           <p:cNvSpPr txBox="1"/>
           <p:nvPr/>
         </p:nvSpPr>
         <p:spPr>
           <a:xfrm>
-            <a:off x="8275320" y="2057400"/>
-            <a:ext cx="3017520" cy="2194560"/>
+            <a:off x="8321040" y="2651760"/>
+            <a:ext cx="2926080" cy="1554480"/>
           </a:xfrm>
           <a:prstGeom prst="rect">
             <a:avLst/>
@@ -4090,23 +4821,26 @@
           <a:lstStyle/>
           <a:p>
             <a:pPr indent="0" marL="0">
+              <a:spcAft>
+                <a:spcPts val="600"/>
+              </a:spcAft>
               <a:buNone/>
             </a:pPr>
             <a:r>
-              <a:rPr lang="en-US" sz="1400" dirty="0">
+              <a:rPr lang="en-US" sz="1600" dirty="0">
                 <a:solidFill>
                   <a:schemeClr val="tx1"/>
                 </a:solidFill>
               </a:rPr>
               <a:t>Weniger Produktion, Lager und Transport</a:t>
             </a:r>
-            <a:endParaRPr lang="en-US" sz="1400" dirty="0"/>
+            <a:endParaRPr lang="en-US" sz="1600" dirty="0"/>
           </a:p>
         </p:txBody>
       </p:sp>
       <p:sp>
         <p:nvSpPr>
-          <p:cNvPr id="13" name="Platzhalter"/>
+          <p:cNvPr id="19" name="Platzhalter"/>
           <p:cNvSpPr/>
           <p:nvPr/>
         </p:nvSpPr>
@@ -4133,7 +4867,7 @@
       </p:sp>
       <p:sp>
         <p:nvSpPr>
-          <p:cNvPr id="14" name="Text 11"/>
+          <p:cNvPr id="20" name="Text 14"/>
           <p:cNvSpPr txBox="1"/>
           <p:nvPr/>
         </p:nvSpPr>
@@ -4278,7 +5012,7 @@
               <a:buNone/>
             </a:pPr>
             <a:r>
-              <a:rPr lang="en-US" sz="3400" b="1" dirty="0">
+              <a:rPr lang="en-US" sz="3600" b="1" dirty="0">
                 <a:solidFill>
                   <a:schemeClr val="tx2"/>
                 </a:solidFill>
@@ -4288,7 +5022,7 @@
               </a:rPr>
               <a:t>Verlauf der Runden im Überblick</a:t>
             </a:r>
-            <a:endParaRPr lang="en-US" sz="3400" dirty="0"/>
+            <a:endParaRPr lang="en-US" sz="3600" dirty="0"/>
           </a:p>
         </p:txBody>
       </p:sp>
@@ -5523,7 +6257,7 @@
               <a:buNone/>
             </a:pPr>
             <a:r>
-              <a:rPr lang="en-US" sz="3400" b="1" dirty="0">
+              <a:rPr lang="en-US" sz="3600" b="1" dirty="0">
                 <a:solidFill>
                   <a:schemeClr val="tx2"/>
                 </a:solidFill>
@@ -5533,7 +6267,7 @@
               </a:rPr>
               <a:t>Unsere Entscheidungen je Runde</a:t>
             </a:r>
-            <a:endParaRPr lang="en-US" sz="3400" dirty="0"/>
+            <a:endParaRPr lang="en-US" sz="3600" dirty="0"/>
           </a:p>
         </p:txBody>
       </p:sp>
@@ -8172,7 +8906,7 @@
               <a:buNone/>
             </a:pPr>
             <a:r>
-              <a:rPr lang="en-US" sz="3400" b="1" dirty="0">
+              <a:rPr lang="en-US" sz="3600" b="1" dirty="0">
                 <a:solidFill>
                   <a:schemeClr val="tx2"/>
                 </a:solidFill>
@@ -8182,7 +8916,7 @@
               </a:rPr>
               <a:t>Wirtschaftsdienst: was von außen auf uns wirkte</a:t>
             </a:r>
-            <a:endParaRPr lang="en-US" sz="3400" dirty="0"/>
+            <a:endParaRPr lang="en-US" sz="3600" dirty="0"/>
           </a:p>
         </p:txBody>
       </p:sp>
@@ -8437,7 +9171,7 @@
               <a:buNone/>
             </a:pPr>
             <a:r>
-              <a:rPr lang="en-US" sz="3400" b="1" dirty="0">
+              <a:rPr lang="en-US" sz="3600" b="1" dirty="0">
                 <a:solidFill>
                   <a:schemeClr val="tx2"/>
                 </a:solidFill>
@@ -8447,7 +9181,7 @@
               </a:rPr>
               <a:t>Auswertung: Kennzahlen pro Runde</a:t>
             </a:r>
-            <a:endParaRPr lang="en-US" sz="3400" dirty="0"/>
+            <a:endParaRPr lang="en-US" sz="3600" dirty="0"/>
           </a:p>
         </p:txBody>
       </p:sp>
@@ -11372,7 +12106,7 @@
         <p:spPr>
           <a:xfrm>
             <a:off x="8138160" y="1463040"/>
-            <a:ext cx="3383280" cy="4023360"/>
+            <a:ext cx="3383280" cy="4206240"/>
           </a:xfrm>
           <a:prstGeom prst="roundRect">
             <a:avLst>
@@ -11387,14 +12121,58 @@
       </p:sp>
       <p:sp>
         <p:nvSpPr>
-          <p:cNvPr id="6" name="Text 2"/>
+          <p:cNvPr id="6" name="Icon-Kreis FaChartLine"/>
+          <p:cNvSpPr/>
+          <p:nvPr/>
+        </p:nvSpPr>
+        <p:spPr>
+          <a:xfrm>
+            <a:off x="8412480" y="1737360"/>
+            <a:ext cx="640080" cy="640080"/>
+          </a:xfrm>
+          <a:prstGeom prst="ellipse">
+            <a:avLst/>
+          </a:prstGeom>
+          <a:solidFill>
+            <a:schemeClr val="accent1"/>
+          </a:solidFill>
+          <a:ln/>
+        </p:spPr>
+      </p:sp>
+      <p:pic>
+        <p:nvPicPr>
+          <p:cNvPr id="7" name="Icon FaChartLine" descr="Symbol">    </p:cNvPr>
+          <p:cNvPicPr>
+            <a:picLocks noChangeAspect="1"/>
+          </p:cNvPicPr>
+          <p:nvPr/>
+        </p:nvPicPr>
+        <p:blipFill>
+          <a:blip r:embed="rId1"/>
+          <a:stretch>
+            <a:fillRect/>
+          </a:stretch>
+        </p:blipFill>
+        <p:spPr>
+          <a:xfrm>
+            <a:off x="8591702" y="1916582"/>
+            <a:ext cx="281635" cy="281635"/>
+          </a:xfrm>
+          <a:prstGeom prst="rect">
+            <a:avLst/>
+          </a:prstGeom>
+        </p:spPr>
+      </p:pic>
+      <p:sp>
+        <p:nvSpPr>
+          <p:cNvPr id="8" name="Text 3"/>
           <p:cNvSpPr txBox="1"/>
           <p:nvPr/>
         </p:nvSpPr>
         <p:spPr>
           <a:xfrm>
-            <a:off x="8366760" y="1600200"/>
-            <a:ext cx="2926080" cy="411480"/>
+            <a:off x="9235440" y="1737360"/>
+            <a:ext cx="2011680" cy="640080"/>
           </a:xfrm>
           <a:prstGeom prst="rect">
             <a:avLst/>
@@ -11410,27 +12188,27 @@
               <a:buNone/>
             </a:pPr>
             <a:r>
-              <a:rPr lang="en-US" sz="1800" b="1" dirty="0">
+              <a:rPr lang="en-US" sz="2000" b="1" dirty="0">
                 <a:solidFill>
                   <a:schemeClr val="tx2"/>
                 </a:solidFill>
               </a:rPr>
               <a:t>So haben wir gerechnet</a:t>
             </a:r>
-            <a:endParaRPr lang="en-US" sz="1800" dirty="0"/>
+            <a:endParaRPr lang="en-US" sz="2000" dirty="0"/>
           </a:p>
         </p:txBody>
       </p:sp>
       <p:sp>
         <p:nvSpPr>
-          <p:cNvPr id="7" name="Text 3"/>
+          <p:cNvPr id="9" name="Text 4"/>
           <p:cNvSpPr txBox="1"/>
           <p:nvPr/>
         </p:nvSpPr>
         <p:spPr>
           <a:xfrm>
-            <a:off x="8366760" y="2057400"/>
-            <a:ext cx="2926080" cy="3291840"/>
+            <a:off x="8412480" y="2651760"/>
+            <a:ext cx="2834640" cy="2834640"/>
           </a:xfrm>
           <a:prstGeom prst="rect">
             <a:avLst/>
@@ -11443,63 +12221,60 @@
           <a:lstStyle/>
           <a:p>
             <a:pPr indent="0" marL="0">
+              <a:spcAft>
+                <a:spcPts val="600"/>
+              </a:spcAft>
               <a:buNone/>
             </a:pPr>
             <a:r>
-              <a:rPr lang="en-US" sz="1400" dirty="0">
+              <a:rPr lang="en-US" sz="1600" dirty="0">
                 <a:solidFill>
                   <a:schemeClr val="tx1"/>
                 </a:solidFill>
               </a:rPr>
-              <a:t>Umsatz = Menge × Preis (+ Schnäppchenmarkt zu 1.000 €/Palette)</a:t>
+              <a:t>Umsatz = Menge × Preis (Rest am Schnäppchenmarkt: 1.000 €/Palette)</a:t>
             </a:r>
-            <a:endParaRPr lang="en-US" sz="1400" dirty="0"/>
+            <a:endParaRPr lang="en-US" sz="1600" dirty="0"/>
           </a:p>
           <a:p>
             <a:pPr indent="0" marL="0">
-              <a:buNone/>
-            </a:pPr>
-            <a:endParaRPr lang="en-US" sz="1400" dirty="0"/>
-          </a:p>
-          <a:p>
-            <a:pPr indent="0" marL="0">
+              <a:spcAft>
+                <a:spcPts val="600"/>
+              </a:spcAft>
               <a:buNone/>
             </a:pPr>
             <a:r>
-              <a:rPr lang="en-US" sz="1400" dirty="0">
+              <a:rPr lang="en-US" sz="1600" dirty="0">
                 <a:solidFill>
                   <a:schemeClr val="tx1"/>
                 </a:solidFill>
               </a:rPr>
-              <a:t>Kosten = Maschinen, Personal, Miete 5.000 €, Produktion, Material</a:t>
+              <a:t>Kosten = Maschinen, Personal, Miete, Produktion, Material</a:t>
             </a:r>
-            <a:endParaRPr lang="en-US" sz="1400" dirty="0"/>
+            <a:endParaRPr lang="en-US" sz="1600" dirty="0"/>
           </a:p>
           <a:p>
             <a:pPr indent="0" marL="0">
-              <a:buNone/>
-            </a:pPr>
-            <a:endParaRPr lang="en-US" sz="1400" dirty="0"/>
-          </a:p>
-          <a:p>
-            <a:pPr indent="0" marL="0">
+              <a:spcAft>
+                <a:spcPts val="600"/>
+              </a:spcAft>
               <a:buNone/>
             </a:pPr>
             <a:r>
-              <a:rPr lang="en-US" sz="1400" dirty="0">
+              <a:rPr lang="en-US" sz="1600" dirty="0">
                 <a:solidFill>
                   <a:schemeClr val="tx1"/>
                 </a:solidFill>
               </a:rPr>
               <a:t>Schlussbestand = Anfangsbestand − Kosten + Umsatz</a:t>
             </a:r>
-            <a:endParaRPr lang="en-US" sz="1400" dirty="0"/>
+            <a:endParaRPr lang="en-US" sz="1600" dirty="0"/>
           </a:p>
         </p:txBody>
       </p:sp>
       <p:sp>
         <p:nvSpPr>
-          <p:cNvPr id="8" name="Text 4"/>
+          <p:cNvPr id="10" name="Text 5"/>
           <p:cNvSpPr txBox="1"/>
           <p:nvPr/>
         </p:nvSpPr>
@@ -11630,7 +12405,7 @@
               <a:buNone/>
             </a:pPr>
             <a:r>
-              <a:rPr lang="en-US" sz="3400" b="1" dirty="0">
+              <a:rPr lang="en-US" sz="3600" b="1" dirty="0">
                 <a:solidFill>
                   <a:schemeClr val="tx2"/>
                 </a:solidFill>
@@ -11640,7 +12415,7 @@
               </a:rPr>
               <a:t>Auswertung: Entwicklung über die Runden</a:t>
             </a:r>
-            <a:endParaRPr lang="en-US" sz="3400" dirty="0"/>
+            <a:endParaRPr lang="en-US" sz="3600" dirty="0"/>
           </a:p>
         </p:txBody>
       </p:sp>
@@ -11967,7 +12742,7 @@
               <a:buNone/>
             </a:pPr>
             <a:r>
-              <a:rPr lang="en-US" sz="3400" b="1" dirty="0">
+              <a:rPr lang="en-US" sz="3600" b="1" dirty="0">
                 <a:solidFill>
                   <a:schemeClr val="tx2"/>
                 </a:solidFill>
@@ -11977,7 +12752,7 @@
               </a:rPr>
               <a:t>Endbestand und Unternehmensverkaufswert</a:t>
             </a:r>
-            <a:endParaRPr lang="en-US" sz="3400" dirty="0"/>
+            <a:endParaRPr lang="en-US" sz="3600" dirty="0"/>
           </a:p>
         </p:txBody>
       </p:sp>

</xml_diff>

<commit_message>
Titelfolie: Gruppenname und Klasse eingetragen
Co-Authored-By: Claude Sonnet 5.5 <noreply@anthropic.com>
Claude-Session: https://claude.ai/code/session_0111joxY9HLNj7w7Z5tgi3FM
</commit_message>
<xml_diff>
--- a/endpraesentation/Elbharz_Endpraesentation_Geruest.pptx
+++ b/endpraesentation/Elbharz_Endpraesentation_Geruest.pptx
@@ -118,38 +118,38 @@
   <p:extLst>
     <p:ext uri="{521415D9-36F7-43E2-AB2F-B90AF26B5E84}">
       <p14:sectionLst xmlns:p14="http://schemas.microsoft.com/office/powerpoint/2010/main">
-        <p14:section name="Einleitung" id="{ff7b473a-1777-88d8-bb7a-b3de1cc8350d}">
+        <p14:section name="Einleitung" id="{2c978acb-694f-8b36-b7c3-e5e95f934328}">
           <p14:sldIdLst>
             <p14:sldId id="256"/>
             <p14:sldId id="257"/>
             <p14:sldId id="258"/>
           </p14:sldIdLst>
         </p14:section>
-        <p14:section name="Verlauf der Runden" id="{69db2324-a497-4912-1220-f62127a58695}">
+        <p14:section name="Verlauf der Runden" id="{910e4e6b-7d87-042a-633c-010422237db8}">
           <p14:sldIdLst>
             <p14:sldId id="259"/>
             <p14:sldId id="260"/>
             <p14:sldId id="261"/>
           </p14:sldIdLst>
         </p14:section>
-        <p14:section name="Auswertung" id="{c2b2d283-98f9-e959-a9f8-8808c35a2e59}">
+        <p14:section name="Auswertung" id="{3df4eb8d-6ba9-2511-9e5b-fed6eb46a0a5}">
           <p14:sldIdLst>
             <p14:sldId id="262"/>
             <p14:sldId id="263"/>
             <p14:sldId id="264"/>
           </p14:sldIdLst>
         </p14:section>
-        <p14:section name="Reflexion" id="{c51abd52-c018-2bdc-c471-4569c6635719}">
+        <p14:section name="Reflexion" id="{55f94074-a051-20b9-3d5a-c1d7aaf69ec0}">
           <p14:sldIdLst>
             <p14:sldId id="265"/>
           </p14:sldIdLst>
         </p14:section>
-        <p14:section name="Bezug zur Gründung" id="{ee985fa3-8cde-6494-d09d-34dafbfe7d29}">
+        <p14:section name="Bezug zur Gründung" id="{6acd1d9f-0f8f-6fa8-d2a9-23fb7735b5dc}">
           <p14:sldIdLst>
             <p14:sldId id="266"/>
           </p14:sldIdLst>
         </p14:section>
-        <p14:section name="Abschluss" id="{280ed113-8599-8367-2ced-d3e4679223ad}">
+        <p14:section name="Abschluss" id="{fc744af7-be2a-b75b-def1-fd5f590d12de}">
           <p14:sldIdLst>
             <p14:sldId id="267"/>
           </p14:sldIdLst>
@@ -2309,7 +2309,7 @@
                   <a:schemeClr val="accent3"/>
                 </a:solidFill>
               </a:rPr>
-              <a:t>Namen der Gruppe · Klasse · Datum</a:t>
+              <a:t>Elbharz Getränke GbR · Klasse 11b</a:t>
             </a:r>
             <a:endParaRPr lang="en-US" sz="1600" dirty="0"/>
           </a:p>

</xml_diff>